<commit_message>
Update presentation, course plan, and demos
</commit_message>
<xml_diff>
--- a/presentation/presentation.pptx
+++ b/presentation/presentation.pptx
@@ -6726,7 +6726,7 @@
                 <a:latin typeface="Noto Sans TC"/>
                 <a:ea typeface="Noto Sans TC"/>
               </a:rPr>
-              <a:t>對話迭代</a:t>
+              <a:t>代理人工作流</a:t>
             </a:r>
             <a:r>
               <a:rPr sz="2800" b="1" i="0">
@@ -6736,7 +6736,7 @@
                 <a:latin typeface="Noto Sans TC"/>
                 <a:ea typeface="Noto Sans TC"/>
               </a:rPr>
-              <a:t>格式與視覺</a:t>
+              <a:t>自動構建</a:t>
             </a:r>
           </a:p>
         </p:txBody>
@@ -6779,7 +6779,7 @@
                 <a:latin typeface="Noto Sans TC"/>
                 <a:ea typeface="Noto Sans TC"/>
               </a:rPr>
-              <a:t>將問卷分析與專案報告轉化為</a:t>
+              <a:t>體驗 Antigravity 原生簡報製作：</a:t>
             </a:r>
             <a:r>
               <a:rPr sz="1600" b="1" i="0">
@@ -6789,7 +6789,7 @@
                 <a:latin typeface="Noto Sans TC"/>
                 <a:ea typeface="Noto Sans TC"/>
               </a:rPr>
-              <a:t>結構化簡報</a:t>
+              <a:t>大綱規劃 → Python 構建 → 視覺驗收</a:t>
             </a:r>
             <a:r>
               <a:rPr sz="1600" b="0" i="0">
@@ -6799,7 +6799,7 @@
                 <a:latin typeface="Noto Sans TC"/>
                 <a:ea typeface="Noto Sans TC"/>
               </a:rPr>
-              <a:t>，直接在對話中微調圖表並匯出至辦公軟體。</a:t>
+              <a:t>，一氣呵成產出可編輯簡報與聯絡單。</a:t>
             </a:r>
           </a:p>
         </p:txBody>
@@ -6963,7 +6963,7 @@
                 <a:latin typeface="Noto Sans TC"/>
                 <a:ea typeface="Noto Sans TC"/>
               </a:rPr>
-              <a:t>資料脈絡載入</a:t>
+              <a:t>資料脈絡注入</a:t>
             </a:r>
           </a:p>
         </p:txBody>
@@ -7053,7 +7053,7 @@
                 <a:latin typeface="Noto Sans TC"/>
                 <a:ea typeface="Noto Sans TC"/>
               </a:rPr>
-              <a:t>「@滿意度調查.csv 這是本季同仁反饋，請先梳理出主要的資料分佈」</a:t>
+              <a:t>「@問卷調查.csv 這是中研院同仁反饋，請分析痛點並規劃 5 頁簡報」</a:t>
             </a:r>
           </a:p>
         </p:txBody>
@@ -7121,7 +7121,7 @@
                 <a:spcPct val="115000"/>
               </a:lnSpc>
               <a:spcAft>
-                <a:spcPts val="700"/>
+                <a:spcPts val="600"/>
               </a:spcAft>
             </a:pPr>
             <a:r>
@@ -7142,7 +7142,7 @@
                 <a:latin typeface="Noto Sans TC"/>
                 <a:ea typeface="Noto Sans TC"/>
               </a:rPr>
-              <a:t>使用 @ 功能精準載入原始資料表格</a:t>
+              <a:t>鍵入 @ 直接引用本機數據與參考文件</a:t>
             </a:r>
           </a:p>
           <a:p>
@@ -7151,7 +7151,7 @@
                 <a:spcPct val="115000"/>
               </a:lnSpc>
               <a:spcAft>
-                <a:spcPts val="700"/>
+                <a:spcPts val="600"/>
               </a:spcAft>
             </a:pPr>
             <a:r>
@@ -7181,7 +7181,7 @@
                 <a:spcPct val="115000"/>
               </a:lnSpc>
               <a:spcAft>
-                <a:spcPts val="700"/>
+                <a:spcPts val="600"/>
               </a:spcAft>
             </a:pPr>
             <a:r>
@@ -7202,7 +7202,7 @@
                 <a:latin typeface="Noto Sans TC"/>
                 <a:ea typeface="Noto Sans TC"/>
               </a:rPr>
-              <a:t>免開 Excel 即可掌握整體統計輪廓</a:t>
+              <a:t>免開 Excel 即可萃取宏觀洞察與趨勢</a:t>
             </a:r>
           </a:p>
         </p:txBody>
@@ -7330,7 +7330,7 @@
                 <a:latin typeface="Noto Sans TC"/>
                 <a:ea typeface="Noto Sans TC"/>
               </a:rPr>
-              <a:t>結構大綱生成</a:t>
+              <a:t>結構大綱規劃</a:t>
             </a:r>
           </a:p>
         </p:txBody>
@@ -7420,7 +7420,7 @@
                 <a:latin typeface="Noto Sans TC"/>
                 <a:ea typeface="Noto Sans TC"/>
               </a:rPr>
-              <a:t>「提煉 3 項核心發現，製作 5 頁正式簡報大綱（摘要/現況/建議）」</a:t>
+              <a:t>「/plan 請擬定 outline.md，明確定義各頁標題、論點與視覺形式」</a:t>
             </a:r>
           </a:p>
         </p:txBody>
@@ -7488,7 +7488,7 @@
                 <a:spcPct val="115000"/>
               </a:lnSpc>
               <a:spcAft>
-                <a:spcPts val="700"/>
+                <a:spcPts val="600"/>
               </a:spcAft>
             </a:pPr>
             <a:r>
@@ -7509,7 +7509,7 @@
                 <a:latin typeface="Noto Sans TC"/>
                 <a:ea typeface="Noto Sans TC"/>
               </a:rPr>
-              <a:t>AI 依據資料自動擬定章節邏輯架構</a:t>
+              <a:t>啟動規劃模式先出具章節結構與規格</a:t>
             </a:r>
           </a:p>
           <a:p>
@@ -7518,7 +7518,7 @@
                 <a:spcPct val="115000"/>
               </a:lnSpc>
               <a:spcAft>
-                <a:spcPts val="700"/>
+                <a:spcPts val="600"/>
               </a:spcAft>
             </a:pPr>
             <a:r>
@@ -7539,7 +7539,7 @@
                 <a:latin typeface="Noto Sans TC"/>
                 <a:ea typeface="Noto Sans TC"/>
               </a:rPr>
-              <a:t>右側 Artifacts 面板即時預覽簡報內容</a:t>
+              <a:t>嚴格依據黃金圈與敘事邏輯排列頁面</a:t>
             </a:r>
           </a:p>
           <a:p>
@@ -7548,7 +7548,7 @@
                 <a:spcPct val="115000"/>
               </a:lnSpc>
               <a:spcAft>
-                <a:spcPts val="700"/>
+                <a:spcPts val="600"/>
               </a:spcAft>
             </a:pPr>
             <a:r>
@@ -7569,7 +7569,7 @@
                 <a:latin typeface="Noto Sans TC"/>
                 <a:ea typeface="Noto Sans TC"/>
               </a:rPr>
-              <a:t>將原始數字轉化為清晰的分析論點</a:t>
+              <a:t>使用者確認大綱無誤後才批准動手</a:t>
             </a:r>
           </a:p>
         </p:txBody>
@@ -7697,7 +7697,7 @@
                 <a:latin typeface="Noto Sans TC"/>
                 <a:ea typeface="Noto Sans TC"/>
               </a:rPr>
-              <a:t>對話持續迭代</a:t>
+              <a:t>Python 原生構建</a:t>
             </a:r>
           </a:p>
         </p:txBody>
@@ -7787,7 +7787,7 @@
                 <a:latin typeface="Noto Sans TC"/>
                 <a:ea typeface="Noto Sans TC"/>
               </a:rPr>
-              <a:t>「第 2 頁改用圓餅圖呈現各單位佔比，語氣改為正式行政風格」</a:t>
+              <a:t>「請調用 python-pptx 構建簡報，嚴格遵循 2pt 格線與暖白配色」</a:t>
             </a:r>
           </a:p>
         </p:txBody>
@@ -7855,7 +7855,7 @@
                 <a:spcPct val="115000"/>
               </a:lnSpc>
               <a:spcAft>
-                <a:spcPts val="700"/>
+                <a:spcPts val="600"/>
               </a:spcAft>
             </a:pPr>
             <a:r>
@@ -7876,7 +7876,7 @@
                 <a:latin typeface="Noto Sans TC"/>
                 <a:ea typeface="Noto Sans TC"/>
               </a:rPr>
-              <a:t>無需從頭重做，直接用中文指定修改頁面</a:t>
+              <a:t>AI 自動撰寫 Python 腳本生成可編輯物件</a:t>
             </a:r>
           </a:p>
           <a:p>
@@ -7885,7 +7885,7 @@
                 <a:spcPct val="115000"/>
               </a:lnSpc>
               <a:spcAft>
-                <a:spcPts val="700"/>
+                <a:spcPts val="600"/>
               </a:spcAft>
             </a:pPr>
             <a:r>
@@ -7906,7 +7906,7 @@
                 <a:latin typeface="Noto Sans TC"/>
                 <a:ea typeface="Noto Sans TC"/>
               </a:rPr>
-              <a:t>動態調整圖表形式、行文語氣與強調重點</a:t>
+              <a:t>非死板截圖，文字、圖表均可手動微調</a:t>
             </a:r>
           </a:p>
           <a:p>
@@ -7915,7 +7915,7 @@
                 <a:spcPct val="115000"/>
               </a:lnSpc>
               <a:spcAft>
-                <a:spcPts val="700"/>
+                <a:spcPts val="600"/>
               </a:spcAft>
             </a:pPr>
             <a:r>
@@ -7936,7 +7936,7 @@
                 <a:latin typeface="Noto Sans TC"/>
                 <a:ea typeface="Noto Sans TC"/>
               </a:rPr>
-              <a:t>每一次修改即時在輔助面板呈現差異</a:t>
+              <a:t>完全符合中研院簡報設計規範與色系</a:t>
             </a:r>
           </a:p>
         </p:txBody>
@@ -8064,7 +8064,7 @@
                 <a:latin typeface="Noto Sans TC"/>
                 <a:ea typeface="Noto Sans TC"/>
               </a:rPr>
-              <a:t>原生格式匯出</a:t>
+              <a:t>視覺彩現驗收</a:t>
             </a:r>
           </a:p>
         </p:txBody>
@@ -8154,7 +8154,7 @@
                 <a:latin typeface="Noto Sans TC"/>
                 <a:ea typeface="Noto Sans TC"/>
               </a:rPr>
-              <a:t>「將這份簡報轉換為可編輯的 PPTX 格式，並保留原始文字區塊」</a:t>
+              <a:t>「導出各頁 PNG 預覽與全覽聯絡單，並轉存 presentation.pdf」</a:t>
             </a:r>
           </a:p>
         </p:txBody>
@@ -8222,7 +8222,7 @@
                 <a:spcPct val="115000"/>
               </a:lnSpc>
               <a:spcAft>
-                <a:spcPts val="700"/>
+                <a:spcPts val="600"/>
               </a:spcAft>
             </a:pPr>
             <a:r>
@@ -8243,7 +8243,7 @@
                 <a:latin typeface="Noto Sans TC"/>
                 <a:ea typeface="Noto Sans TC"/>
               </a:rPr>
-              <a:t>產出原生 PowerPoint 檔案，非死板截圖</a:t>
+              <a:t>自動產生單頁預覽圖與 20 頁總覽聯絡單</a:t>
             </a:r>
           </a:p>
           <a:p>
@@ -8252,7 +8252,7 @@
                 <a:spcPct val="115000"/>
               </a:lnSpc>
               <a:spcAft>
-                <a:spcPts val="700"/>
+                <a:spcPts val="600"/>
               </a:spcAft>
             </a:pPr>
             <a:r>
@@ -8273,7 +8273,7 @@
                 <a:latin typeface="Noto Sans TC"/>
                 <a:ea typeface="Noto Sans TC"/>
               </a:rPr>
-              <a:t>支援匯入 Google Slides 供團隊線上協作</a:t>
+              <a:t>免開啟 PowerPoint 即可即時檢驗排版</a:t>
             </a:r>
           </a:p>
           <a:p>
@@ -8282,7 +8282,7 @@
                 <a:spcPct val="115000"/>
               </a:lnSpc>
               <a:spcAft>
-                <a:spcPts val="700"/>
+                <a:spcPts val="600"/>
               </a:spcAft>
             </a:pPr>
             <a:r>
@@ -8303,7 +8303,7 @@
                 <a:latin typeface="Noto Sans TC"/>
                 <a:ea typeface="Noto Sans TC"/>
               </a:rPr>
-              <a:t>節省 80% 手動排版與格式複製貼上工時</a:t>
+              <a:t>支援匯入 Google Slides 供團隊線上協作</a:t>
             </a:r>
           </a:p>
         </p:txBody>

</xml_diff>

<commit_message>
Refactor slides for Governance Deep Dive: Update slide 19 to focus on Plan Review Policy and slide 20 on Security Preset. Add new slide 21 for practical checklist and follow-up resources. Update slide_story.md to reflect changes in slide count and content. Add new UI images for Antigravity.
</commit_message>
<xml_diff>
--- a/presentation/presentation.pptx
+++ b/presentation/presentation.pptx
@@ -25,6 +25,7 @@
     <p:sldId id="273" r:id="rId24"/>
     <p:sldId id="274" r:id="rId25"/>
     <p:sldId id="275" r:id="rId26"/>
+    <p:sldId id="276" r:id="rId27"/>
   </p:sldIdLst>
   <p:sldSz cx="12191695" cy="6858000" type="screen4x3"/>
   <p:notesSz cx="6858000" cy="9144000"/>
@@ -3460,6 +3461,31 @@
           </a:p>
         </p:txBody>
       </p:sp>
+      <p:pic>
+        <p:nvPicPr>
+          <p:cNvPr id="10" name="Picture 9" descr="antigravity-icon.png"/>
+          <p:cNvPicPr>
+            <a:picLocks noChangeAspect="1"/>
+          </p:cNvPicPr>
+          <p:nvPr/>
+        </p:nvPicPr>
+        <p:blipFill>
+          <a:blip r:embed="rId2"/>
+          <a:stretch>
+            <a:fillRect/>
+          </a:stretch>
+        </p:blipFill>
+        <p:spPr>
+          <a:xfrm>
+            <a:off x="566928" y="1115568"/>
+            <a:ext cx="843340" cy="777240"/>
+          </a:xfrm>
+          <a:prstGeom prst="rect">
+            <a:avLst/>
+          </a:prstGeom>
+          <a:effectLst/>
+        </p:spPr>
+      </p:pic>
     </p:spTree>
   </p:cSld>
   <p:clrMapOvr>
@@ -12150,7 +12176,7 @@
                 <a:latin typeface="Noto Sans TC"/>
                 <a:ea typeface="Noto Sans TC"/>
               </a:rPr>
-              <a:t>代理人協作的</a:t>
+              <a:t>超越單次對話：以 </a:t>
             </a:r>
             <a:r>
               <a:rPr sz="2800" b="1" i="0">
@@ -12160,7 +12186,7 @@
                 <a:latin typeface="Noto Sans TC"/>
                 <a:ea typeface="Noto Sans TC"/>
               </a:rPr>
-              <a:t>三大防線</a:t>
+              <a:t>Skills、MCP 與 Plugins</a:t>
             </a:r>
             <a:r>
               <a:rPr sz="2800" b="1" i="0">
@@ -12170,7 +12196,7 @@
                 <a:latin typeface="Noto Sans TC"/>
                 <a:ea typeface="Noto Sans TC"/>
               </a:rPr>
-              <a:t>：計畫審核、資料隔離與結果查驗</a:t>
+              <a:t> 打造長期專屬生產力</a:t>
             </a:r>
           </a:p>
         </p:txBody>
@@ -12213,7 +12239,7 @@
                 <a:latin typeface="Noto Sans TC"/>
                 <a:ea typeface="Noto Sans TC"/>
               </a:rPr>
-              <a:t>在充分享受自動化便利的同時，必須確保</a:t>
+              <a:t>擺脫單次重複下指令的繁瑣，透過</a:t>
             </a:r>
             <a:r>
               <a:rPr sz="1600" b="1" i="0">
@@ -12223,7 +12249,7 @@
                 <a:latin typeface="Noto Sans TC"/>
                 <a:ea typeface="Noto Sans TC"/>
               </a:rPr>
-              <a:t>資安合規</a:t>
+              <a:t>技能沉澱流程、協議連接外部工具、外掛模組化分發</a:t>
             </a:r>
             <a:r>
               <a:rPr sz="1600" b="0" i="0">
@@ -12233,27 +12259,7 @@
                 <a:latin typeface="Noto Sans TC"/>
                 <a:ea typeface="Noto Sans TC"/>
               </a:rPr>
-              <a:t>與</a:t>
-            </a:r>
-            <a:r>
-              <a:rPr sz="1600" b="1" i="0">
-                <a:solidFill>
-                  <a:srgbClr val="1A1714"/>
-                </a:solidFill>
-                <a:latin typeface="Noto Sans TC"/>
-                <a:ea typeface="Noto Sans TC"/>
-              </a:rPr>
-              <a:t>學術資料嚴謹性</a:t>
-            </a:r>
-            <a:r>
-              <a:rPr sz="1600" b="0" i="0">
-                <a:solidFill>
-                  <a:srgbClr val="8A8177"/>
-                </a:solidFill>
-                <a:latin typeface="Noto Sans TC"/>
-                <a:ea typeface="Noto Sans TC"/>
-              </a:rPr>
-              <a:t>，築牢風險防線。</a:t>
+              <a:t>，將 AI 升級為組織級的專屬專家。</a:t>
             </a:r>
           </a:p>
         </p:txBody>
@@ -12397,7 +12403,7 @@
                 <a:latin typeface="Noto Sans TC"/>
                 <a:ea typeface="Noto Sans TC"/>
               </a:rPr>
-              <a:t>執行把關</a:t>
+              <a:t>流程沉澱</a:t>
             </a:r>
           </a:p>
         </p:txBody>
@@ -12437,7 +12443,7 @@
                 <a:latin typeface="Consolas"/>
                 <a:ea typeface="Consolas"/>
               </a:rPr>
-              <a:t>防線 01</a:t>
+              <a:t>架構 01</a:t>
             </a:r>
           </a:p>
         </p:txBody>
@@ -12477,7 +12483,7 @@
                 <a:latin typeface="Noto Sans TC"/>
                 <a:ea typeface="Noto Sans TC"/>
               </a:rPr>
-              <a:t>永遠先確認計畫再放行</a:t>
+              <a:t>Agent Skills (技能庫)</a:t>
             </a:r>
           </a:p>
           <a:p>
@@ -12494,7 +12500,7 @@
                 <a:latin typeface="Noto Sans TC"/>
                 <a:ea typeface="Noto Sans TC"/>
               </a:rPr>
-              <a:t>特別防範涉及檔案移動、覆蓋與刪除的操作</a:t>
+              <a:t>多步驟 SOP 封裝為標準 Runbook</a:t>
             </a:r>
           </a:p>
         </p:txBody>
@@ -12573,7 +12579,7 @@
                 <a:latin typeface="Noto Sans TC"/>
                 <a:ea typeface="Noto Sans TC"/>
               </a:rPr>
-              <a:t>▸ 先列清單原則：</a:t>
+              <a:t>▸ 漸進加載機制：</a:t>
             </a:r>
             <a:r>
               <a:rPr sz="1200" b="0" i="0">
@@ -12583,7 +12589,7 @@
                 <a:latin typeface="Noto Sans TC"/>
                 <a:ea typeface="Noto Sans TC"/>
               </a:rPr>
-              <a:t>下達破壞性或搬遷指令時，要求 AI 先提供預計變更對照表。</a:t>
+              <a:t>平時僅加載名稱與描述，按需喚醒完整指令，大幅節省 Token。</a:t>
             </a:r>
           </a:p>
           <a:p>
@@ -12603,7 +12609,7 @@
                 <a:latin typeface="Noto Sans TC"/>
                 <a:ea typeface="Noto Sans TC"/>
               </a:rPr>
-              <a:t>▸ 善用異動面板：</a:t>
+              <a:t>▸ 結構化流程包：</a:t>
             </a:r>
             <a:r>
               <a:rPr sz="1200" b="0" i="0">
@@ -12613,7 +12619,7 @@
                 <a:latin typeface="Noto Sans TC"/>
                 <a:ea typeface="Noto Sans TC"/>
               </a:rPr>
-              <a:t>在 Files Changed 輔助窗格逐一核對異動路徑，確認無誤再放行。</a:t>
+              <a:t>包含 SKILL.md 指引、輔助 scripts、範例與自訂驗證步驟。</a:t>
             </a:r>
           </a:p>
           <a:p>
@@ -12633,7 +12639,7 @@
                 <a:latin typeface="Noto Sans TC"/>
                 <a:ea typeface="Noto Sans TC"/>
               </a:rPr>
-              <a:t>▸ 保留原始備份：</a:t>
+              <a:t>▸ 版本控制共用：</a:t>
             </a:r>
             <a:r>
               <a:rPr sz="1200" b="0" i="0">
@@ -12643,7 +12649,7 @@
                 <a:latin typeface="Noto Sans TC"/>
                 <a:ea typeface="Noto Sans TC"/>
               </a:rPr>
-              <a:t>執行批次整理前，建議將原始資料夾進行本機封存或快照備份。</a:t>
+              <a:t>存放於 .agents/skills/，隨專案 Git 簽入，團隊成員開箱即用。</a:t>
             </a:r>
           </a:p>
         </p:txBody>
@@ -12713,7 +12719,7 @@
             </a:avLst>
           </a:prstGeom>
           <a:solidFill>
-            <a:srgbClr val="C13227"/>
+            <a:srgbClr val="D75F00"/>
           </a:solidFill>
           <a:ln>
             <a:noFill/>
@@ -12751,7 +12757,7 @@
                 <a:latin typeface="Noto Sans TC"/>
                 <a:ea typeface="Noto Sans TC"/>
               </a:rPr>
-              <a:t>資安紅線</a:t>
+              <a:t>工具擴充</a:t>
             </a:r>
           </a:p>
         </p:txBody>
@@ -12791,7 +12797,7 @@
                 <a:latin typeface="Consolas"/>
                 <a:ea typeface="Consolas"/>
               </a:rPr>
-              <a:t>防線 02</a:t>
+              <a:t>架構 02</a:t>
             </a:r>
           </a:p>
         </p:txBody>
@@ -12831,7 +12837,7 @@
                 <a:latin typeface="Noto Sans TC"/>
                 <a:ea typeface="Noto Sans TC"/>
               </a:rPr>
-              <a:t>機密與個人隱私嚴格隔離</a:t>
+              <a:t>MCP 外部協議</a:t>
             </a:r>
           </a:p>
           <a:p>
@@ -12848,7 +12854,7 @@
                 <a:latin typeface="Noto Sans TC"/>
                 <a:ea typeface="Noto Sans TC"/>
               </a:rPr>
-              <a:t>未公開的學術研究資料與個資不上傳雲端</a:t>
+              <a:t>開放標準通訊連接外部資料與系統</a:t>
             </a:r>
           </a:p>
         </p:txBody>
@@ -12927,7 +12933,7 @@
                 <a:latin typeface="Noto Sans TC"/>
                 <a:ea typeface="Noto Sans TC"/>
               </a:rPr>
-              <a:t>▸ 敏感資料不上傳：</a:t>
+              <a:t>▸ 通用開放協議：</a:t>
             </a:r>
             <a:r>
               <a:rPr sz="1200" b="0" i="0">
@@ -12937,7 +12943,7 @@
                 <a:latin typeface="Noto Sans TC"/>
                 <a:ea typeface="Noto Sans TC"/>
               </a:rPr>
-              <a:t>涉及人體受試者個資、人事隱私、未公開論文草稿禁止直接上傳。</a:t>
+              <a:t>支援本機 Stdio 進程與遠端 SSE 串流，安全開放外部工具調用。</a:t>
             </a:r>
           </a:p>
           <a:p>
@@ -12957,7 +12963,7 @@
                 <a:latin typeface="Noto Sans TC"/>
                 <a:ea typeface="Noto Sans TC"/>
               </a:rPr>
-              <a:t>▸ 脫敏演練習慣：</a:t>
+              <a:t>▸ 串接內部資源：</a:t>
             </a:r>
             <a:r>
               <a:rPr sz="1200" b="0" i="0">
@@ -12967,7 +12973,7 @@
                 <a:latin typeface="Noto Sans TC"/>
                 <a:ea typeface="Noto Sans TC"/>
               </a:rPr>
-              <a:t>教學與日常測試一律使用脫敏假資料或公開資料集進行演練。</a:t>
+              <a:t>透過 mcp_config.json 介接院內資料庫、私有 API 或本機系統。</a:t>
             </a:r>
           </a:p>
           <a:p>
@@ -12987,7 +12993,7 @@
                 <a:latin typeface="Noto Sans TC"/>
                 <a:ea typeface="Noto Sans TC"/>
               </a:rPr>
-              <a:t>▸ 遵循院內規範：</a:t>
+              <a:t>▸ 動態工具探索：</a:t>
             </a:r>
             <a:r>
               <a:rPr sz="1200" b="0" i="0">
@@ -12997,7 +13003,7 @@
                 <a:latin typeface="Noto Sans TC"/>
                 <a:ea typeface="Noto Sans TC"/>
               </a:rPr>
-              <a:t>遵循中研院資通安全管理作業準則，確認模型與外網通訊權限。</a:t>
+              <a:t>啟動自動註冊 Tools 到 AI 工具箱，擺脫手動複製貼上。</a:t>
             </a:r>
           </a:p>
         </p:txBody>
@@ -13105,7 +13111,7 @@
                 <a:latin typeface="Noto Sans TC"/>
                 <a:ea typeface="Noto Sans TC"/>
               </a:rPr>
-              <a:t>嚴謹驗收</a:t>
+              <a:t>生態分發</a:t>
             </a:r>
           </a:p>
         </p:txBody>
@@ -13145,7 +13151,7 @@
                 <a:latin typeface="Consolas"/>
                 <a:ea typeface="Consolas"/>
               </a:rPr>
-              <a:t>防線 03</a:t>
+              <a:t>架構 03</a:t>
             </a:r>
           </a:p>
         </p:txBody>
@@ -13185,7 +13191,7 @@
                 <a:latin typeface="Noto Sans TC"/>
                 <a:ea typeface="Noto Sans TC"/>
               </a:rPr>
-              <a:t>產出資料與引用人工查驗</a:t>
+              <a:t>Plugins (外掛套件)</a:t>
             </a:r>
           </a:p>
           <a:p>
@@ -13202,7 +13208,7 @@
                 <a:latin typeface="Noto Sans TC"/>
                 <a:ea typeface="Noto Sans TC"/>
               </a:rPr>
-              <a:t>AI 擔任提速實習生，最終成果責任在人類</a:t>
+              <a:t>模組化整合與團隊一鍵分發大禮包</a:t>
             </a:r>
           </a:p>
         </p:txBody>
@@ -13281,7 +13287,7 @@
                 <a:latin typeface="Noto Sans TC"/>
                 <a:ea typeface="Noto Sans TC"/>
               </a:rPr>
-              <a:t>▸ 查驗數字統計：</a:t>
+              <a:t>▸ 全功能打包袋：</a:t>
             </a:r>
             <a:r>
               <a:rPr sz="1200" b="0" i="0">
@@ -13291,7 +13297,7 @@
                 <a:latin typeface="Noto Sans TC"/>
                 <a:ea typeface="Noto Sans TC"/>
               </a:rPr>
-              <a:t>LLM 可能存在計算或幻覺風險，簡報內的關鍵統計務必二次覆核。</a:t>
+              <a:t>以 plugin.json 為核心，整合 Skills、Rules、MCP 與 Hooks。</a:t>
             </a:r>
           </a:p>
           <a:p>
@@ -13311,7 +13317,7 @@
                 <a:latin typeface="Noto Sans TC"/>
                 <a:ea typeface="Noto Sans TC"/>
               </a:rPr>
-              <a:t>▸ 點選外部連結：</a:t>
+              <a:t>▸ 獨立命名空間：</a:t>
             </a:r>
             <a:r>
               <a:rPr sz="1200" b="0" i="0">
@@ -13321,7 +13327,7 @@
                 <a:latin typeface="Noto Sans TC"/>
                 <a:ea typeface="Noto Sans TC"/>
               </a:rPr>
-              <a:t>AI 爬蟲或整理之文獻連結與法規條文，發布前手動抽驗有效性。</a:t>
+              <a:t>有效防止跨專案工具與規則命名衝突，權限清晰獨立。</a:t>
             </a:r>
           </a:p>
           <a:p>
@@ -13341,7 +13347,7 @@
                 <a:latin typeface="Noto Sans TC"/>
                 <a:ea typeface="Noto Sans TC"/>
               </a:rPr>
-              <a:t>▸ 人類負責任簽核：</a:t>
+              <a:t>▸ 彈性開關管理：</a:t>
             </a:r>
             <a:r>
               <a:rPr sz="1200" b="0" i="0">
@@ -13351,7 +13357,7 @@
                 <a:latin typeface="Noto Sans TC"/>
                 <a:ea typeface="Noto Sans TC"/>
               </a:rPr>
-              <a:t>AI 產出之公文簽呈與專案報告，由承辦與研究同仁承擔簽定責任。</a:t>
+              <a:t>可透過設定介面或 CLI 自由啟用/停用，依專案需求抽換。</a:t>
             </a:r>
           </a:p>
         </p:txBody>
@@ -13463,24 +13469,34 @@
               </a:spcAft>
             </a:pPr>
             <a:r>
-              <a:rPr sz="2600" b="1" i="0">
+              <a:rPr sz="2800" b="1" i="0">
+                <a:solidFill>
+                  <a:srgbClr val="1A1714"/>
+                </a:solidFill>
+                <a:latin typeface="Noto Sans TC"/>
+                <a:ea typeface="Noto Sans TC"/>
+              </a:rPr>
+              <a:t>代理人協作的</a:t>
+            </a:r>
+            <a:r>
+              <a:rPr sz="2800" b="1" i="0">
                 <a:solidFill>
                   <a:srgbClr val="D75F00"/>
                 </a:solidFill>
                 <a:latin typeface="Noto Sans TC"/>
                 <a:ea typeface="Noto Sans TC"/>
               </a:rPr>
-              <a:t>防線一實體設定：計畫審核機制</a:t>
-            </a:r>
-            <a:r>
-              <a:rPr sz="2600" b="1" i="0">
+              <a:t>三大防線</a:t>
+            </a:r>
+            <a:r>
+              <a:rPr sz="2800" b="1" i="0">
                 <a:solidFill>
                   <a:srgbClr val="1A1714"/>
                 </a:solidFill>
                 <a:latin typeface="Noto Sans TC"/>
                 <a:ea typeface="Noto Sans TC"/>
               </a:rPr>
-              <a:t>：以 Always Ask 阻斷非預期檔案異動</a:t>
+              <a:t>：計畫審核、資料隔離與結果查驗</a:t>
             </a:r>
           </a:p>
         </p:txBody>
@@ -13523,7 +13539,7 @@
                 <a:latin typeface="Noto Sans TC"/>
                 <a:ea typeface="Noto Sans TC"/>
               </a:rPr>
-              <a:t>在動手前先看計畫：將</a:t>
+              <a:t>在充分享受自動化便利的同時，必須確保</a:t>
             </a:r>
             <a:r>
               <a:rPr sz="1600" b="1" i="0">
@@ -13533,7 +13549,7 @@
                 <a:latin typeface="Noto Sans TC"/>
                 <a:ea typeface="Noto Sans TC"/>
               </a:rPr>
-              <a:t>Plan Review Policy 設為 Always Ask</a:t>
+              <a:t>資安合規</a:t>
             </a:r>
             <a:r>
               <a:rPr sz="1600" b="0" i="0">
@@ -13543,7 +13559,27 @@
                 <a:latin typeface="Noto Sans TC"/>
                 <a:ea typeface="Noto Sans TC"/>
               </a:rPr>
-              <a:t>，杜絕任何未經確認的本機檔案覆蓋與刪除。</a:t>
+              <a:t>與</a:t>
+            </a:r>
+            <a:r>
+              <a:rPr sz="1600" b="1" i="0">
+                <a:solidFill>
+                  <a:srgbClr val="1A1714"/>
+                </a:solidFill>
+                <a:latin typeface="Noto Sans TC"/>
+                <a:ea typeface="Noto Sans TC"/>
+              </a:rPr>
+              <a:t>學術資料嚴謹性</a:t>
+            </a:r>
+            <a:r>
+              <a:rPr sz="1600" b="0" i="0">
+                <a:solidFill>
+                  <a:srgbClr val="8A8177"/>
+                </a:solidFill>
+                <a:latin typeface="Noto Sans TC"/>
+                <a:ea typeface="Noto Sans TC"/>
+              </a:rPr>
+              <a:t>，築牢風險防線。</a:t>
             </a:r>
           </a:p>
         </p:txBody>
@@ -13584,150 +13620,16 @@
           </a:fontRef>
         </p:style>
       </p:cxnSp>
-      <p:pic>
-        <p:nvPicPr>
-          <p:cNvPr id="6" name="Picture 5" descr="settings-general2.png"/>
-          <p:cNvPicPr>
-            <a:picLocks noChangeAspect="1"/>
-          </p:cNvPicPr>
-          <p:nvPr/>
-        </p:nvPicPr>
-        <p:blipFill>
-          <a:blip r:embed="rId2"/>
-          <a:stretch>
-            <a:fillRect/>
-          </a:stretch>
-        </p:blipFill>
+      <p:sp>
+        <p:nvSpPr>
+          <p:cNvPr id="6" name="Rounded Rectangle 5"/>
+          <p:cNvSpPr/>
+          <p:nvPr/>
+        </p:nvSpPr>
         <p:spPr>
           <a:xfrm>
             <a:off x="566928" y="2240280"/>
-            <a:ext cx="6520914" cy="4160519"/>
-          </a:xfrm>
-          <a:prstGeom prst="rect">
-            <a:avLst/>
-          </a:prstGeom>
-          <a:ln w="12700">
-            <a:solidFill>
-              <a:srgbClr val="E4DED4"/>
-            </a:solidFill>
-          </a:ln>
-          <a:effectLst/>
-        </p:spPr>
-      </p:pic>
-      <p:sp>
-        <p:nvSpPr>
-          <p:cNvPr id="7" name="Rectangle 6"/>
-          <p:cNvSpPr/>
-          <p:nvPr/>
-        </p:nvSpPr>
-        <p:spPr>
-          <a:xfrm>
-            <a:off x="2377440" y="2788920"/>
-            <a:ext cx="3977639" cy="594360"/>
-          </a:xfrm>
-          <a:prstGeom prst="rect">
-            <a:avLst/>
-          </a:prstGeom>
-          <a:noFill/>
-          <a:ln w="28575">
-            <a:solidFill>
-              <a:srgbClr val="D75F00"/>
-            </a:solidFill>
-          </a:ln>
-          <a:effectLst/>
-        </p:spPr>
-        <p:style>
-          <a:lnRef idx="1">
-            <a:schemeClr val="accent1"/>
-          </a:lnRef>
-          <a:fillRef idx="3">
-            <a:schemeClr val="accent1"/>
-          </a:fillRef>
-          <a:effectRef idx="2">
-            <a:schemeClr val="accent1"/>
-          </a:effectRef>
-          <a:fontRef idx="minor">
-            <a:schemeClr val="lt1"/>
-          </a:fontRef>
-        </p:style>
-        <p:txBody>
-          <a:bodyPr rtlCol="0" anchor="ctr"/>
-          <a:lstStyle/>
-          <a:p>
-            <a:pPr algn="ctr"/>
-          </a:p>
-        </p:txBody>
-      </p:sp>
-      <p:sp>
-        <p:nvSpPr>
-          <p:cNvPr id="8" name="Rounded Rectangle 7"/>
-          <p:cNvSpPr/>
-          <p:nvPr/>
-        </p:nvSpPr>
-        <p:spPr>
-          <a:xfrm>
-            <a:off x="3246119" y="2532888"/>
-            <a:ext cx="3063240" cy="219456"/>
-          </a:xfrm>
-          <a:prstGeom prst="roundRect">
-            <a:avLst>
-              <a:gd name="adj" fmla="val 50000"/>
-            </a:avLst>
-          </a:prstGeom>
-          <a:solidFill>
-            <a:srgbClr val="D75F00"/>
-          </a:solidFill>
-          <a:ln>
-            <a:noFill/>
-          </a:ln>
-          <a:effectLst/>
-        </p:spPr>
-        <p:style>
-          <a:lnRef idx="1">
-            <a:schemeClr val="accent1"/>
-          </a:lnRef>
-          <a:fillRef idx="3">
-            <a:schemeClr val="accent1"/>
-          </a:fillRef>
-          <a:effectRef idx="2">
-            <a:schemeClr val="accent1"/>
-          </a:effectRef>
-          <a:fontRef idx="minor">
-            <a:schemeClr val="lt1"/>
-          </a:fontRef>
-        </p:style>
-        <p:txBody>
-          <a:bodyPr rtlCol="0" anchor="ctr" lIns="36576" rIns="36576" tIns="0" bIns="0" wrap="none"/>
-          <a:lstStyle/>
-          <a:p>
-            <a:pPr algn="ctr">
-              <a:spcAft>
-                <a:spcPts val="400"/>
-              </a:spcAft>
-            </a:pPr>
-            <a:r>
-              <a:rPr sz="1200" b="1" i="0">
-                <a:solidFill>
-                  <a:srgbClr val="F5F2EC"/>
-                </a:solidFill>
-                <a:latin typeface="Noto Sans TC"/>
-                <a:ea typeface="Noto Sans TC"/>
-              </a:rPr>
-              <a:t>★ 關鍵設定：Plan Review Policy = Always Ask</a:t>
-            </a:r>
-          </a:p>
-        </p:txBody>
-      </p:sp>
-      <p:sp>
-        <p:nvSpPr>
-          <p:cNvPr id="9" name="Rounded Rectangle 8"/>
-          <p:cNvSpPr/>
-          <p:nvPr/>
-        </p:nvSpPr>
-        <p:spPr>
-          <a:xfrm>
-            <a:off x="7406640" y="2240280"/>
-            <a:ext cx="4215384" cy="4160520"/>
+            <a:ext cx="3511296" cy="4160520"/>
           </a:xfrm>
           <a:prstGeom prst="roundRect">
             <a:avLst>
@@ -13768,14 +13670,74 @@
       </p:sp>
       <p:sp>
         <p:nvSpPr>
-          <p:cNvPr id="10" name="TextBox 9"/>
+          <p:cNvPr id="7" name="Rounded Rectangle 6"/>
+          <p:cNvSpPr/>
+          <p:nvPr/>
+        </p:nvSpPr>
+        <p:spPr>
+          <a:xfrm>
+            <a:off x="786384" y="2441448"/>
+            <a:ext cx="1005840" cy="237744"/>
+          </a:xfrm>
+          <a:prstGeom prst="roundRect">
+            <a:avLst>
+              <a:gd name="adj" fmla="val 50000"/>
+            </a:avLst>
+          </a:prstGeom>
+          <a:solidFill>
+            <a:srgbClr val="1A1714"/>
+          </a:solidFill>
+          <a:ln>
+            <a:noFill/>
+          </a:ln>
+          <a:effectLst/>
+        </p:spPr>
+        <p:style>
+          <a:lnRef idx="1">
+            <a:schemeClr val="accent1"/>
+          </a:lnRef>
+          <a:fillRef idx="3">
+            <a:schemeClr val="accent1"/>
+          </a:fillRef>
+          <a:effectRef idx="2">
+            <a:schemeClr val="accent1"/>
+          </a:effectRef>
+          <a:fontRef idx="minor">
+            <a:schemeClr val="lt1"/>
+          </a:fontRef>
+        </p:style>
+        <p:txBody>
+          <a:bodyPr rtlCol="0" anchor="ctr" lIns="36576" rIns="36576" tIns="0" bIns="0" wrap="none"/>
+          <a:lstStyle/>
+          <a:p>
+            <a:pPr algn="ctr">
+              <a:spcAft>
+                <a:spcPts val="400"/>
+              </a:spcAft>
+            </a:pPr>
+            <a:r>
+              <a:rPr sz="1200" b="1" i="0">
+                <a:solidFill>
+                  <a:srgbClr val="F5F2EC"/>
+                </a:solidFill>
+                <a:latin typeface="Noto Sans TC"/>
+                <a:ea typeface="Noto Sans TC"/>
+              </a:rPr>
+              <a:t>執行把關</a:t>
+            </a:r>
+          </a:p>
+        </p:txBody>
+      </p:sp>
+      <p:sp>
+        <p:nvSpPr>
+          <p:cNvPr id="8" name="TextBox 7"/>
           <p:cNvSpPr txBox="1"/>
           <p:nvPr/>
         </p:nvSpPr>
         <p:spPr>
           <a:xfrm>
-            <a:off x="7589520" y="2404872"/>
-            <a:ext cx="3849624" cy="256032"/>
+            <a:off x="1892808" y="2441448"/>
+            <a:ext cx="1956816" cy="274320"/>
           </a:xfrm>
           <a:prstGeom prst="rect">
             <a:avLst/>
@@ -13796,36 +13758,26 @@
             <a:r>
               <a:rPr sz="1200" b="1" i="0">
                 <a:solidFill>
-                  <a:srgbClr val="D75F00"/>
+                  <a:srgbClr val="8A8177"/>
                 </a:solidFill>
                 <a:latin typeface="Consolas"/>
                 <a:ea typeface="Consolas"/>
               </a:rPr>
-              <a:t>EXECUTION SAFEGUARD  ·  </a:t>
-            </a:r>
-            <a:r>
-              <a:rPr sz="1200" b="0" i="0">
-                <a:solidFill>
-                  <a:srgbClr val="8A8177"/>
-                </a:solidFill>
-                <a:latin typeface="Noto Sans TC"/>
-                <a:ea typeface="Noto Sans TC"/>
-              </a:rPr>
-              <a:t>執行把關防線</a:t>
-            </a:r>
-          </a:p>
-        </p:txBody>
-      </p:sp>
-      <p:sp>
-        <p:nvSpPr>
-          <p:cNvPr id="11" name="TextBox 10"/>
+              <a:t>防線 01</a:t>
+            </a:r>
+          </a:p>
+        </p:txBody>
+      </p:sp>
+      <p:sp>
+        <p:nvSpPr>
+          <p:cNvPr id="9" name="TextBox 8"/>
           <p:cNvSpPr txBox="1"/>
           <p:nvPr/>
         </p:nvSpPr>
         <p:spPr>
           <a:xfrm>
-            <a:off x="7589520" y="2679192"/>
-            <a:ext cx="3849624" cy="347472"/>
+            <a:off x="786384" y="2807208"/>
+            <a:ext cx="3072384" cy="594360"/>
           </a:xfrm>
           <a:prstGeom prst="rect">
             <a:avLst/>
@@ -13840,32 +13792,49 @@
           <a:p>
             <a:pPr algn="l">
               <a:spcAft>
+                <a:spcPts val="300"/>
+              </a:spcAft>
+            </a:pPr>
+            <a:r>
+              <a:rPr sz="2000" b="1" i="0">
+                <a:solidFill>
+                  <a:srgbClr val="1A1714"/>
+                </a:solidFill>
+                <a:latin typeface="Noto Sans TC"/>
+                <a:ea typeface="Noto Sans TC"/>
+              </a:rPr>
+              <a:t>永遠先確認計畫再放行</a:t>
+            </a:r>
+          </a:p>
+          <a:p>
+            <a:pPr algn="l">
+              <a:spcAft>
                 <a:spcPts val="400"/>
               </a:spcAft>
             </a:pPr>
             <a:r>
-              <a:rPr sz="1600" b="1" i="0">
-                <a:solidFill>
-                  <a:srgbClr val="1A1714"/>
-                </a:solidFill>
-                <a:latin typeface="Noto Sans TC"/>
-                <a:ea typeface="Noto Sans TC"/>
-              </a:rPr>
-              <a:t>堅持「先看計畫再放行」的操作原則</a:t>
+              <a:rPr sz="1200" b="0" i="0">
+                <a:solidFill>
+                  <a:srgbClr val="4A443D"/>
+                </a:solidFill>
+                <a:latin typeface="Noto Sans TC"/>
+                <a:ea typeface="Noto Sans TC"/>
+              </a:rPr>
+              <a:t>特別防範涉及檔案移動、覆蓋與刪除的操作</a:t>
             </a:r>
           </a:p>
         </p:txBody>
       </p:sp>
       <p:cxnSp>
         <p:nvCxnSpPr>
-          <p:cNvPr id="12" name="Connector 11"/>
+          <p:cNvPr id="10" name="Connector 9"/>
           <p:cNvCxnSpPr/>
           <p:nvPr/>
         </p:nvCxnSpPr>
         <p:spPr>
           <a:xfrm>
-            <a:off x="7589520" y="3081528"/>
-            <a:ext cx="3849624" cy="0"/>
+            <a:off x="786384" y="3593592"/>
+            <a:ext cx="3072384" cy="0"/>
           </a:xfrm>
           <a:prstGeom prst="line">
             <a:avLst/>
@@ -13894,14 +13863,14 @@
       </p:cxnSp>
       <p:sp>
         <p:nvSpPr>
-          <p:cNvPr id="13" name="TextBox 12"/>
+          <p:cNvPr id="11" name="TextBox 10"/>
           <p:cNvSpPr txBox="1"/>
           <p:nvPr/>
         </p:nvSpPr>
         <p:spPr>
           <a:xfrm>
-            <a:off x="7589520" y="3191256"/>
-            <a:ext cx="3849624" cy="3108960"/>
+            <a:off x="786384" y="3721608"/>
+            <a:ext cx="3072384" cy="2468880"/>
           </a:xfrm>
           <a:prstGeom prst="rect">
             <a:avLst/>
@@ -13915,6 +13884,187 @@
           <a:lstStyle/>
           <a:p>
             <a:pPr algn="l">
+              <a:lnSpc>
+                <a:spcPct val="120000"/>
+              </a:lnSpc>
+              <a:spcAft>
+                <a:spcPts val="1200"/>
+              </a:spcAft>
+            </a:pPr>
+            <a:r>
+              <a:rPr sz="1400" b="1" i="0">
+                <a:solidFill>
+                  <a:srgbClr val="1A1714"/>
+                </a:solidFill>
+                <a:latin typeface="Noto Sans TC"/>
+                <a:ea typeface="Noto Sans TC"/>
+              </a:rPr>
+              <a:t>▸ 先列清單原則：</a:t>
+            </a:r>
+            <a:r>
+              <a:rPr sz="1200" b="0" i="0">
+                <a:solidFill>
+                  <a:srgbClr val="4A443D"/>
+                </a:solidFill>
+                <a:latin typeface="Noto Sans TC"/>
+                <a:ea typeface="Noto Sans TC"/>
+              </a:rPr>
+              <a:t>下達破壞性或搬遷指令時，要求 AI 先提供預計變更對照表。</a:t>
+            </a:r>
+          </a:p>
+          <a:p>
+            <a:pPr algn="l">
+              <a:lnSpc>
+                <a:spcPct val="120000"/>
+              </a:lnSpc>
+              <a:spcAft>
+                <a:spcPts val="1200"/>
+              </a:spcAft>
+            </a:pPr>
+            <a:r>
+              <a:rPr sz="1400" b="1" i="0">
+                <a:solidFill>
+                  <a:srgbClr val="1A1714"/>
+                </a:solidFill>
+                <a:latin typeface="Noto Sans TC"/>
+                <a:ea typeface="Noto Sans TC"/>
+              </a:rPr>
+              <a:t>▸ 善用異動面板：</a:t>
+            </a:r>
+            <a:r>
+              <a:rPr sz="1200" b="0" i="0">
+                <a:solidFill>
+                  <a:srgbClr val="4A443D"/>
+                </a:solidFill>
+                <a:latin typeface="Noto Sans TC"/>
+                <a:ea typeface="Noto Sans TC"/>
+              </a:rPr>
+              <a:t>在 Files Changed 輔助窗格逐一核對異動路徑，確認無誤再放行。</a:t>
+            </a:r>
+          </a:p>
+          <a:p>
+            <a:pPr algn="l">
+              <a:lnSpc>
+                <a:spcPct val="120000"/>
+              </a:lnSpc>
+              <a:spcAft>
+                <a:spcPts val="1200"/>
+              </a:spcAft>
+            </a:pPr>
+            <a:r>
+              <a:rPr sz="1400" b="1" i="0">
+                <a:solidFill>
+                  <a:srgbClr val="1A1714"/>
+                </a:solidFill>
+                <a:latin typeface="Noto Sans TC"/>
+                <a:ea typeface="Noto Sans TC"/>
+              </a:rPr>
+              <a:t>▸ 保留原始備份：</a:t>
+            </a:r>
+            <a:r>
+              <a:rPr sz="1200" b="0" i="0">
+                <a:solidFill>
+                  <a:srgbClr val="4A443D"/>
+                </a:solidFill>
+                <a:latin typeface="Noto Sans TC"/>
+                <a:ea typeface="Noto Sans TC"/>
+              </a:rPr>
+              <a:t>執行批次整理前，建議將原始資料夾進行本機封存或快照備份。</a:t>
+            </a:r>
+          </a:p>
+        </p:txBody>
+      </p:sp>
+      <p:sp>
+        <p:nvSpPr>
+          <p:cNvPr id="12" name="Rounded Rectangle 11"/>
+          <p:cNvSpPr/>
+          <p:nvPr/>
+        </p:nvSpPr>
+        <p:spPr>
+          <a:xfrm>
+            <a:off x="4334256" y="2240280"/>
+            <a:ext cx="3511296" cy="4160520"/>
+          </a:xfrm>
+          <a:prstGeom prst="roundRect">
+            <a:avLst>
+              <a:gd name="adj" fmla="val 6000"/>
+            </a:avLst>
+          </a:prstGeom>
+          <a:solidFill>
+            <a:srgbClr val="F6E3D2"/>
+          </a:solidFill>
+          <a:ln w="19050">
+            <a:solidFill>
+              <a:srgbClr val="D75F00"/>
+            </a:solidFill>
+          </a:ln>
+          <a:effectLst/>
+        </p:spPr>
+        <p:style>
+          <a:lnRef idx="1">
+            <a:schemeClr val="accent1"/>
+          </a:lnRef>
+          <a:fillRef idx="3">
+            <a:schemeClr val="accent1"/>
+          </a:fillRef>
+          <a:effectRef idx="2">
+            <a:schemeClr val="accent1"/>
+          </a:effectRef>
+          <a:fontRef idx="minor">
+            <a:schemeClr val="lt1"/>
+          </a:fontRef>
+        </p:style>
+        <p:txBody>
+          <a:bodyPr rtlCol="0" anchor="ctr"/>
+          <a:lstStyle/>
+          <a:p>
+            <a:pPr algn="ctr"/>
+          </a:p>
+        </p:txBody>
+      </p:sp>
+      <p:sp>
+        <p:nvSpPr>
+          <p:cNvPr id="13" name="Rounded Rectangle 12"/>
+          <p:cNvSpPr/>
+          <p:nvPr/>
+        </p:nvSpPr>
+        <p:spPr>
+          <a:xfrm>
+            <a:off x="4553712" y="2441448"/>
+            <a:ext cx="1005840" cy="237744"/>
+          </a:xfrm>
+          <a:prstGeom prst="roundRect">
+            <a:avLst>
+              <a:gd name="adj" fmla="val 50000"/>
+            </a:avLst>
+          </a:prstGeom>
+          <a:solidFill>
+            <a:srgbClr val="C13227"/>
+          </a:solidFill>
+          <a:ln>
+            <a:noFill/>
+          </a:ln>
+          <a:effectLst/>
+        </p:spPr>
+        <p:style>
+          <a:lnRef idx="1">
+            <a:schemeClr val="accent1"/>
+          </a:lnRef>
+          <a:fillRef idx="3">
+            <a:schemeClr val="accent1"/>
+          </a:fillRef>
+          <a:effectRef idx="2">
+            <a:schemeClr val="accent1"/>
+          </a:effectRef>
+          <a:fontRef idx="minor">
+            <a:schemeClr val="lt1"/>
+          </a:fontRef>
+        </p:style>
+        <p:txBody>
+          <a:bodyPr rtlCol="0" anchor="ctr" lIns="36576" rIns="36576" tIns="0" bIns="0" wrap="none"/>
+          <a:lstStyle/>
+          <a:p>
+            <a:pPr algn="ctr">
               <a:spcAft>
                 <a:spcPts val="400"/>
               </a:spcAft>
@@ -13922,33 +14072,454 @@
             <a:r>
               <a:rPr sz="1200" b="1" i="0">
                 <a:solidFill>
+                  <a:srgbClr val="F5F2EC"/>
+                </a:solidFill>
+                <a:latin typeface="Noto Sans TC"/>
+                <a:ea typeface="Noto Sans TC"/>
+              </a:rPr>
+              <a:t>資安紅線</a:t>
+            </a:r>
+          </a:p>
+        </p:txBody>
+      </p:sp>
+      <p:sp>
+        <p:nvSpPr>
+          <p:cNvPr id="14" name="TextBox 13"/>
+          <p:cNvSpPr txBox="1"/>
+          <p:nvPr/>
+        </p:nvSpPr>
+        <p:spPr>
+          <a:xfrm>
+            <a:off x="5660136" y="2441448"/>
+            <a:ext cx="1956816" cy="274320"/>
+          </a:xfrm>
+          <a:prstGeom prst="rect">
+            <a:avLst/>
+          </a:prstGeom>
+          <a:noFill/>
+        </p:spPr>
+        <p:txBody>
+          <a:bodyPr wrap="square" anchor="t" lIns="0" rIns="0" tIns="0" bIns="0">
+            <a:spAutoFit/>
+          </a:bodyPr>
+          <a:lstStyle/>
+          <a:p>
+            <a:pPr algn="l">
+              <a:spcAft>
+                <a:spcPts val="400"/>
+              </a:spcAft>
+            </a:pPr>
+            <a:r>
+              <a:rPr sz="1200" b="1" i="0">
+                <a:solidFill>
                   <a:srgbClr val="D75F00"/>
                 </a:solidFill>
-                <a:latin typeface="Noto Sans TC"/>
-                <a:ea typeface="Noto Sans TC"/>
-              </a:rPr>
-              <a:t>① Always Ask 的防護機制</a:t>
-            </a:r>
-          </a:p>
+                <a:latin typeface="Consolas"/>
+                <a:ea typeface="Consolas"/>
+              </a:rPr>
+              <a:t>防線 02</a:t>
+            </a:r>
+          </a:p>
+        </p:txBody>
+      </p:sp>
+      <p:sp>
+        <p:nvSpPr>
+          <p:cNvPr id="15" name="TextBox 14"/>
+          <p:cNvSpPr txBox="1"/>
+          <p:nvPr/>
+        </p:nvSpPr>
+        <p:spPr>
+          <a:xfrm>
+            <a:off x="4553712" y="2807208"/>
+            <a:ext cx="3072384" cy="594360"/>
+          </a:xfrm>
+          <a:prstGeom prst="rect">
+            <a:avLst/>
+          </a:prstGeom>
+          <a:noFill/>
+        </p:spPr>
+        <p:txBody>
+          <a:bodyPr wrap="square" anchor="t" lIns="0" rIns="0" tIns="0" bIns="0">
+            <a:spAutoFit/>
+          </a:bodyPr>
+          <a:lstStyle/>
+          <a:p>
+            <a:pPr algn="l">
+              <a:spcAft>
+                <a:spcPts val="300"/>
+              </a:spcAft>
+            </a:pPr>
+            <a:r>
+              <a:rPr sz="2000" b="1" i="0">
+                <a:solidFill>
+                  <a:srgbClr val="1A1714"/>
+                </a:solidFill>
+                <a:latin typeface="Noto Sans TC"/>
+                <a:ea typeface="Noto Sans TC"/>
+              </a:rPr>
+              <a:t>機密與個人隱私嚴格隔離</a:t>
+            </a:r>
+          </a:p>
+          <a:p>
+            <a:pPr algn="l">
+              <a:spcAft>
+                <a:spcPts val="400"/>
+              </a:spcAft>
+            </a:pPr>
+            <a:r>
+              <a:rPr sz="1200" b="0" i="0">
+                <a:solidFill>
+                  <a:srgbClr val="4A443D"/>
+                </a:solidFill>
+                <a:latin typeface="Noto Sans TC"/>
+                <a:ea typeface="Noto Sans TC"/>
+              </a:rPr>
+              <a:t>未公開的學術研究資料與個資不上傳雲端</a:t>
+            </a:r>
+          </a:p>
+        </p:txBody>
+      </p:sp>
+      <p:cxnSp>
+        <p:nvCxnSpPr>
+          <p:cNvPr id="16" name="Connector 15"/>
+          <p:cNvCxnSpPr/>
+          <p:nvPr/>
+        </p:nvCxnSpPr>
+        <p:spPr>
+          <a:xfrm>
+            <a:off x="4553712" y="3593592"/>
+            <a:ext cx="3072384" cy="0"/>
+          </a:xfrm>
+          <a:prstGeom prst="line">
+            <a:avLst/>
+          </a:prstGeom>
+          <a:ln w="12700">
+            <a:solidFill>
+              <a:srgbClr val="D75F00"/>
+            </a:solidFill>
+          </a:ln>
+          <a:effectLst/>
+        </p:spPr>
+        <p:style>
+          <a:lnRef idx="2">
+            <a:schemeClr val="accent1"/>
+          </a:lnRef>
+          <a:fillRef idx="0">
+            <a:schemeClr val="accent1"/>
+          </a:fillRef>
+          <a:effectRef idx="1">
+            <a:schemeClr val="accent1"/>
+          </a:effectRef>
+          <a:fontRef idx="minor">
+            <a:schemeClr val="tx1"/>
+          </a:fontRef>
+        </p:style>
+      </p:cxnSp>
+      <p:sp>
+        <p:nvSpPr>
+          <p:cNvPr id="17" name="TextBox 16"/>
+          <p:cNvSpPr txBox="1"/>
+          <p:nvPr/>
+        </p:nvSpPr>
+        <p:spPr>
+          <a:xfrm>
+            <a:off x="4553712" y="3721608"/>
+            <a:ext cx="3072384" cy="2468880"/>
+          </a:xfrm>
+          <a:prstGeom prst="rect">
+            <a:avLst/>
+          </a:prstGeom>
+          <a:noFill/>
+        </p:spPr>
+        <p:txBody>
+          <a:bodyPr wrap="square" anchor="t" lIns="0" rIns="0" tIns="0" bIns="0">
+            <a:spAutoFit/>
+          </a:bodyPr>
+          <a:lstStyle/>
           <a:p>
             <a:pPr algn="l">
               <a:lnSpc>
-                <a:spcPct val="118000"/>
+                <a:spcPct val="120000"/>
               </a:lnSpc>
               <a:spcAft>
+                <a:spcPts val="1200"/>
+              </a:spcAft>
+            </a:pPr>
+            <a:r>
+              <a:rPr sz="1400" b="1" i="0">
+                <a:solidFill>
+                  <a:srgbClr val="D75F00"/>
+                </a:solidFill>
+                <a:latin typeface="Noto Sans TC"/>
+                <a:ea typeface="Noto Sans TC"/>
+              </a:rPr>
+              <a:t>▸ 敏感資料不上傳：</a:t>
+            </a:r>
+            <a:r>
+              <a:rPr sz="1200" b="0" i="0">
+                <a:solidFill>
+                  <a:srgbClr val="4A443D"/>
+                </a:solidFill>
+                <a:latin typeface="Noto Sans TC"/>
+                <a:ea typeface="Noto Sans TC"/>
+              </a:rPr>
+              <a:t>涉及人體受試者個資、人事隱私、未公開論文草稿禁止直接上傳。</a:t>
+            </a:r>
+          </a:p>
+          <a:p>
+            <a:pPr algn="l">
+              <a:lnSpc>
+                <a:spcPct val="120000"/>
+              </a:lnSpc>
+              <a:spcAft>
+                <a:spcPts val="1200"/>
+              </a:spcAft>
+            </a:pPr>
+            <a:r>
+              <a:rPr sz="1400" b="1" i="0">
+                <a:solidFill>
+                  <a:srgbClr val="D75F00"/>
+                </a:solidFill>
+                <a:latin typeface="Noto Sans TC"/>
+                <a:ea typeface="Noto Sans TC"/>
+              </a:rPr>
+              <a:t>▸ 脫敏演練習慣：</a:t>
+            </a:r>
+            <a:r>
+              <a:rPr sz="1200" b="0" i="0">
+                <a:solidFill>
+                  <a:srgbClr val="4A443D"/>
+                </a:solidFill>
+                <a:latin typeface="Noto Sans TC"/>
+                <a:ea typeface="Noto Sans TC"/>
+              </a:rPr>
+              <a:t>教學與日常測試一律使用脫敏假資料或公開資料集進行演練。</a:t>
+            </a:r>
+          </a:p>
+          <a:p>
+            <a:pPr algn="l">
+              <a:lnSpc>
+                <a:spcPct val="120000"/>
+              </a:lnSpc>
+              <a:spcAft>
+                <a:spcPts val="1200"/>
+              </a:spcAft>
+            </a:pPr>
+            <a:r>
+              <a:rPr sz="1400" b="1" i="0">
+                <a:solidFill>
+                  <a:srgbClr val="D75F00"/>
+                </a:solidFill>
+                <a:latin typeface="Noto Sans TC"/>
+                <a:ea typeface="Noto Sans TC"/>
+              </a:rPr>
+              <a:t>▸ 遵循院內規範：</a:t>
+            </a:r>
+            <a:r>
+              <a:rPr sz="1200" b="0" i="0">
+                <a:solidFill>
+                  <a:srgbClr val="4A443D"/>
+                </a:solidFill>
+                <a:latin typeface="Noto Sans TC"/>
+                <a:ea typeface="Noto Sans TC"/>
+              </a:rPr>
+              <a:t>遵循中研院資通安全管理作業準則，確認模型與外網通訊權限。</a:t>
+            </a:r>
+          </a:p>
+        </p:txBody>
+      </p:sp>
+      <p:sp>
+        <p:nvSpPr>
+          <p:cNvPr id="18" name="Rounded Rectangle 17"/>
+          <p:cNvSpPr/>
+          <p:nvPr/>
+        </p:nvSpPr>
+        <p:spPr>
+          <a:xfrm>
+            <a:off x="8101584" y="2240280"/>
+            <a:ext cx="3511296" cy="4160520"/>
+          </a:xfrm>
+          <a:prstGeom prst="roundRect">
+            <a:avLst>
+              <a:gd name="adj" fmla="val 6000"/>
+            </a:avLst>
+          </a:prstGeom>
+          <a:solidFill>
+            <a:srgbClr val="FFFFFE"/>
+          </a:solidFill>
+          <a:ln w="12700">
+            <a:solidFill>
+              <a:srgbClr val="E4DED4"/>
+            </a:solidFill>
+          </a:ln>
+          <a:effectLst/>
+        </p:spPr>
+        <p:style>
+          <a:lnRef idx="1">
+            <a:schemeClr val="accent1"/>
+          </a:lnRef>
+          <a:fillRef idx="3">
+            <a:schemeClr val="accent1"/>
+          </a:fillRef>
+          <a:effectRef idx="2">
+            <a:schemeClr val="accent1"/>
+          </a:effectRef>
+          <a:fontRef idx="minor">
+            <a:schemeClr val="lt1"/>
+          </a:fontRef>
+        </p:style>
+        <p:txBody>
+          <a:bodyPr rtlCol="0" anchor="ctr"/>
+          <a:lstStyle/>
+          <a:p>
+            <a:pPr algn="ctr"/>
+          </a:p>
+        </p:txBody>
+      </p:sp>
+      <p:sp>
+        <p:nvSpPr>
+          <p:cNvPr id="19" name="Rounded Rectangle 18"/>
+          <p:cNvSpPr/>
+          <p:nvPr/>
+        </p:nvSpPr>
+        <p:spPr>
+          <a:xfrm>
+            <a:off x="8321040" y="2441448"/>
+            <a:ext cx="1005840" cy="237744"/>
+          </a:xfrm>
+          <a:prstGeom prst="roundRect">
+            <a:avLst>
+              <a:gd name="adj" fmla="val 50000"/>
+            </a:avLst>
+          </a:prstGeom>
+          <a:solidFill>
+            <a:srgbClr val="1A1714"/>
+          </a:solidFill>
+          <a:ln>
+            <a:noFill/>
+          </a:ln>
+          <a:effectLst/>
+        </p:spPr>
+        <p:style>
+          <a:lnRef idx="1">
+            <a:schemeClr val="accent1"/>
+          </a:lnRef>
+          <a:fillRef idx="3">
+            <a:schemeClr val="accent1"/>
+          </a:fillRef>
+          <a:effectRef idx="2">
+            <a:schemeClr val="accent1"/>
+          </a:effectRef>
+          <a:fontRef idx="minor">
+            <a:schemeClr val="lt1"/>
+          </a:fontRef>
+        </p:style>
+        <p:txBody>
+          <a:bodyPr rtlCol="0" anchor="ctr" lIns="36576" rIns="36576" tIns="0" bIns="0" wrap="none"/>
+          <a:lstStyle/>
+          <a:p>
+            <a:pPr algn="ctr">
+              <a:spcAft>
+                <a:spcPts val="400"/>
+              </a:spcAft>
+            </a:pPr>
+            <a:r>
+              <a:rPr sz="1200" b="1" i="0">
+                <a:solidFill>
+                  <a:srgbClr val="F5F2EC"/>
+                </a:solidFill>
+                <a:latin typeface="Noto Sans TC"/>
+                <a:ea typeface="Noto Sans TC"/>
+              </a:rPr>
+              <a:t>嚴謹驗收</a:t>
+            </a:r>
+          </a:p>
+        </p:txBody>
+      </p:sp>
+      <p:sp>
+        <p:nvSpPr>
+          <p:cNvPr id="20" name="TextBox 19"/>
+          <p:cNvSpPr txBox="1"/>
+          <p:nvPr/>
+        </p:nvSpPr>
+        <p:spPr>
+          <a:xfrm>
+            <a:off x="9427464" y="2441448"/>
+            <a:ext cx="1956816" cy="274320"/>
+          </a:xfrm>
+          <a:prstGeom prst="rect">
+            <a:avLst/>
+          </a:prstGeom>
+          <a:noFill/>
+        </p:spPr>
+        <p:txBody>
+          <a:bodyPr wrap="square" anchor="t" lIns="0" rIns="0" tIns="0" bIns="0">
+            <a:spAutoFit/>
+          </a:bodyPr>
+          <a:lstStyle/>
+          <a:p>
+            <a:pPr algn="l">
+              <a:spcAft>
+                <a:spcPts val="400"/>
+              </a:spcAft>
+            </a:pPr>
+            <a:r>
+              <a:rPr sz="1200" b="1" i="0">
+                <a:solidFill>
+                  <a:srgbClr val="8A8177"/>
+                </a:solidFill>
+                <a:latin typeface="Consolas"/>
+                <a:ea typeface="Consolas"/>
+              </a:rPr>
+              <a:t>防線 03</a:t>
+            </a:r>
+          </a:p>
+        </p:txBody>
+      </p:sp>
+      <p:sp>
+        <p:nvSpPr>
+          <p:cNvPr id="21" name="TextBox 20"/>
+          <p:cNvSpPr txBox="1"/>
+          <p:nvPr/>
+        </p:nvSpPr>
+        <p:spPr>
+          <a:xfrm>
+            <a:off x="8321040" y="2807208"/>
+            <a:ext cx="3072384" cy="594360"/>
+          </a:xfrm>
+          <a:prstGeom prst="rect">
+            <a:avLst/>
+          </a:prstGeom>
+          <a:noFill/>
+        </p:spPr>
+        <p:txBody>
+          <a:bodyPr wrap="square" anchor="t" lIns="0" rIns="0" tIns="0" bIns="0">
+            <a:spAutoFit/>
+          </a:bodyPr>
+          <a:lstStyle/>
+          <a:p>
+            <a:pPr algn="l">
+              <a:spcAft>
                 <a:spcPts val="300"/>
               </a:spcAft>
             </a:pPr>
             <a:r>
-              <a:rPr sz="1200" b="1" i="0">
+              <a:rPr sz="2000" b="1" i="0">
                 <a:solidFill>
                   <a:srgbClr val="1A1714"/>
                 </a:solidFill>
                 <a:latin typeface="Noto Sans TC"/>
                 <a:ea typeface="Noto Sans TC"/>
               </a:rPr>
-              <a:t>▸ 強制中斷等待批准：</a:t>
-            </a:r>
+              <a:t>產出資料與引用人工查驗</a:t>
+            </a:r>
+          </a:p>
+          <a:p>
+            <a:pPr algn="l">
+              <a:spcAft>
+                <a:spcPts val="400"/>
+              </a:spcAft>
+            </a:pPr>
             <a:r>
               <a:rPr sz="1200" b="0" i="0">
                 <a:solidFill>
@@ -13957,27 +14528,86 @@
                 <a:latin typeface="Noto Sans TC"/>
                 <a:ea typeface="Noto Sans TC"/>
               </a:rPr>
-              <a:t>遇批次檔案移動、刪除或覆蓋，AI 必須停手呈報計畫。</a:t>
-            </a:r>
-          </a:p>
+              <a:t>AI 擔任提速實習生，最終成果責任在人類</a:t>
+            </a:r>
+          </a:p>
+        </p:txBody>
+      </p:sp>
+      <p:cxnSp>
+        <p:nvCxnSpPr>
+          <p:cNvPr id="22" name="Connector 21"/>
+          <p:cNvCxnSpPr/>
+          <p:nvPr/>
+        </p:nvCxnSpPr>
+        <p:spPr>
+          <a:xfrm>
+            <a:off x="8321040" y="3593592"/>
+            <a:ext cx="3072384" cy="0"/>
+          </a:xfrm>
+          <a:prstGeom prst="line">
+            <a:avLst/>
+          </a:prstGeom>
+          <a:ln w="12700">
+            <a:solidFill>
+              <a:srgbClr val="DED8CE"/>
+            </a:solidFill>
+          </a:ln>
+          <a:effectLst/>
+        </p:spPr>
+        <p:style>
+          <a:lnRef idx="2">
+            <a:schemeClr val="accent1"/>
+          </a:lnRef>
+          <a:fillRef idx="0">
+            <a:schemeClr val="accent1"/>
+          </a:fillRef>
+          <a:effectRef idx="1">
+            <a:schemeClr val="accent1"/>
+          </a:effectRef>
+          <a:fontRef idx="minor">
+            <a:schemeClr val="tx1"/>
+          </a:fontRef>
+        </p:style>
+      </p:cxnSp>
+      <p:sp>
+        <p:nvSpPr>
+          <p:cNvPr id="23" name="TextBox 22"/>
+          <p:cNvSpPr txBox="1"/>
+          <p:nvPr/>
+        </p:nvSpPr>
+        <p:spPr>
+          <a:xfrm>
+            <a:off x="8321040" y="3721608"/>
+            <a:ext cx="3072384" cy="2468880"/>
+          </a:xfrm>
+          <a:prstGeom prst="rect">
+            <a:avLst/>
+          </a:prstGeom>
+          <a:noFill/>
+        </p:spPr>
+        <p:txBody>
+          <a:bodyPr wrap="square" anchor="t" lIns="0" rIns="0" tIns="0" bIns="0">
+            <a:spAutoFit/>
+          </a:bodyPr>
+          <a:lstStyle/>
           <a:p>
             <a:pPr algn="l">
               <a:lnSpc>
-                <a:spcPct val="118000"/>
+                <a:spcPct val="120000"/>
               </a:lnSpc>
               <a:spcAft>
-                <a:spcPts val="0"/>
-              </a:spcAft>
-            </a:pPr>
-            <a:r>
-              <a:rPr sz="1200" b="1" i="0">
+                <a:spcPts val="1200"/>
+              </a:spcAft>
+            </a:pPr>
+            <a:r>
+              <a:rPr sz="1400" b="1" i="0">
                 <a:solidFill>
                   <a:srgbClr val="1A1714"/>
                 </a:solidFill>
                 <a:latin typeface="Noto Sans TC"/>
                 <a:ea typeface="Noto Sans TC"/>
               </a:rPr>
-              <a:t>▸ 點選 Proceed 始得執行：</a:t>
+              <a:t>▸ 查驗數字統計：</a:t>
             </a:r>
             <a:r>
               <a:rPr sz="1200" b="0" i="0">
@@ -13987,47 +14617,27 @@
                 <a:latin typeface="Noto Sans TC"/>
                 <a:ea typeface="Noto Sans TC"/>
               </a:rPr>
-              <a:t>只有使用者在介面確認計畫無誤後，代理人才獲准動手。</a:t>
-            </a:r>
-          </a:p>
-          <a:p>
-            <a:pPr algn="l">
-              <a:spcBef>
-                <a:spcPts val="800"/>
-              </a:spcBef>
-              <a:spcAft>
-                <a:spcPts val="400"/>
-              </a:spcAft>
-            </a:pPr>
-            <a:r>
-              <a:rPr sz="1200" b="1" i="0">
-                <a:solidFill>
-                  <a:srgbClr val="D75F00"/>
-                </a:solidFill>
-                <a:latin typeface="Noto Sans TC"/>
-                <a:ea typeface="Noto Sans TC"/>
-              </a:rPr>
-              <a:t>② 善用 /plan 斜線指令</a:t>
+              <a:t>LLM 可能存在計算或幻覺風險，簡報內的關鍵統計務必二次覆核。</a:t>
             </a:r>
           </a:p>
           <a:p>
             <a:pPr algn="l">
               <a:lnSpc>
-                <a:spcPct val="118000"/>
+                <a:spcPct val="120000"/>
               </a:lnSpc>
               <a:spcAft>
-                <a:spcPts val="300"/>
-              </a:spcAft>
-            </a:pPr>
-            <a:r>
-              <a:rPr sz="1200" b="1" i="0">
+                <a:spcPts val="1200"/>
+              </a:spcAft>
+            </a:pPr>
+            <a:r>
+              <a:rPr sz="1400" b="1" i="0">
                 <a:solidFill>
                   <a:srgbClr val="1A1714"/>
                 </a:solidFill>
                 <a:latin typeface="Noto Sans TC"/>
                 <a:ea typeface="Noto Sans TC"/>
               </a:rPr>
-              <a:t>▸ 主動啟動規劃模式：</a:t>
+              <a:t>▸ 點選外部連結：</a:t>
             </a:r>
             <a:r>
               <a:rPr sz="1200" b="0" i="0">
@@ -14037,27 +14647,27 @@
                 <a:latin typeface="Noto Sans TC"/>
                 <a:ea typeface="Noto Sans TC"/>
               </a:rPr>
-              <a:t>複雜任務前輸入 /plan，要求 AI 先梳理步驟清單與邊界。</a:t>
+              <a:t>AI 爬蟲或整理之文獻連結與法規條文，發布前手動抽驗有效性。</a:t>
             </a:r>
           </a:p>
           <a:p>
             <a:pPr algn="l">
               <a:lnSpc>
-                <a:spcPct val="118000"/>
+                <a:spcPct val="120000"/>
               </a:lnSpc>
               <a:spcAft>
-                <a:spcPts val="0"/>
-              </a:spcAft>
-            </a:pPr>
-            <a:r>
-              <a:rPr sz="1200" b="1" i="0">
+                <a:spcPts val="1200"/>
+              </a:spcAft>
+            </a:pPr>
+            <a:r>
+              <a:rPr sz="1400" b="1" i="0">
                 <a:solidFill>
                   <a:srgbClr val="1A1714"/>
                 </a:solidFill>
                 <a:latin typeface="Noto Sans TC"/>
                 <a:ea typeface="Noto Sans TC"/>
               </a:rPr>
-              <a:t>▸ 消除 95% 溝通落差：</a:t>
+              <a:t>▸ 人類負責任簽核：</a:t>
             </a:r>
             <a:r>
               <a:rPr sz="1200" b="0" i="0">
@@ -14067,57 +14677,7 @@
                 <a:latin typeface="Noto Sans TC"/>
                 <a:ea typeface="Noto Sans TC"/>
               </a:rPr>
-              <a:t>在投入實際修改前釐清目錄、格式與邏輯，大幅降低試錯成本。</a:t>
-            </a:r>
-          </a:p>
-          <a:p>
-            <a:pPr algn="l">
-              <a:spcBef>
-                <a:spcPts val="800"/>
-              </a:spcBef>
-              <a:spcAft>
-                <a:spcPts val="400"/>
-              </a:spcAft>
-            </a:pPr>
-            <a:r>
-              <a:rPr sz="1200" b="1" i="0">
-                <a:solidFill>
-                  <a:srgbClr val="D75F00"/>
-                </a:solidFill>
-                <a:latin typeface="Noto Sans TC"/>
-                <a:ea typeface="Noto Sans TC"/>
-              </a:rPr>
-              <a:t>③ 中研院職員最佳實踐</a:t>
-            </a:r>
-          </a:p>
-          <a:p>
-            <a:pPr algn="l">
-              <a:lnSpc>
-                <a:spcPct val="118000"/>
-              </a:lnSpc>
-              <a:spcAft>
-                <a:spcPts val="0"/>
-              </a:spcAft>
-            </a:pPr>
-            <a:r>
-              <a:rPr sz="1200" b="1" i="0">
-                <a:solidFill>
-                  <a:srgbClr val="1A1714"/>
-                </a:solidFill>
-                <a:latin typeface="Noto Sans TC"/>
-                <a:ea typeface="Noto Sans TC"/>
-              </a:rPr>
-              <a:t>▸ 禁止切換為 Never Ask：</a:t>
-            </a:r>
-            <a:r>
-              <a:rPr sz="1200" b="0" i="0">
-                <a:solidFill>
-                  <a:srgbClr val="4A443D"/>
-                </a:solidFill>
-                <a:latin typeface="Noto Sans TC"/>
-                <a:ea typeface="Noto Sans TC"/>
-              </a:rPr>
-              <a:t>日常行政與學術研究嚴禁關閉計畫確認，保持操作透明可稽。</a:t>
+              <a:t>AI 產出之公文簽呈與專案報告，由承辦與研究同仁承擔簽定責任。</a:t>
             </a:r>
           </a:p>
         </p:txBody>
@@ -14229,24 +14789,24 @@
               </a:spcAft>
             </a:pPr>
             <a:r>
-              <a:rPr sz="2800" b="1" i="0">
+              <a:rPr sz="2600" b="1" i="0">
                 <a:solidFill>
                   <a:srgbClr val="D75F00"/>
                 </a:solidFill>
                 <a:latin typeface="Noto Sans TC"/>
                 <a:ea typeface="Noto Sans TC"/>
               </a:rPr>
-              <a:t>防線二實體設定：安全沙箱等級</a:t>
-            </a:r>
-            <a:r>
-              <a:rPr sz="2800" b="1" i="0">
+              <a:t>防線一實體設定：計畫審核機制</a:t>
+            </a:r>
+            <a:r>
+              <a:rPr sz="2600" b="1" i="0">
                 <a:solidFill>
                   <a:srgbClr val="1A1714"/>
                 </a:solidFill>
                 <a:latin typeface="Noto Sans TC"/>
                 <a:ea typeface="Noto Sans TC"/>
               </a:rPr>
-              <a:t>：堅守 Default 預設沙箱防護隔離</a:t>
+              <a:t>：以 Always Ask 阻斷非預期檔案異動</a:t>
             </a:r>
           </a:p>
         </p:txBody>
@@ -14289,7 +14849,7 @@
                 <a:latin typeface="Noto Sans TC"/>
                 <a:ea typeface="Noto Sans TC"/>
               </a:rPr>
-              <a:t>把守資安邊界：將</a:t>
+              <a:t>在動手前先看計畫：將</a:t>
             </a:r>
             <a:r>
               <a:rPr sz="1600" b="1" i="0">
@@ -14299,7 +14859,7 @@
                 <a:latin typeface="Noto Sans TC"/>
                 <a:ea typeface="Noto Sans TC"/>
               </a:rPr>
-              <a:t>Security Preset 維持為 Default</a:t>
+              <a:t>Plan Review Policy 設為 Always Ask</a:t>
             </a:r>
             <a:r>
               <a:rPr sz="1600" b="0" i="0">
@@ -14309,7 +14869,7 @@
                 <a:latin typeface="Noto Sans TC"/>
                 <a:ea typeface="Noto Sans TC"/>
               </a:rPr>
-              <a:t>，所有終端指令與跨目錄檔案存取皆需人工逐條審查。</a:t>
+              <a:t>，杜絕任何未經確認的本機檔案覆蓋與刪除。</a:t>
             </a:r>
           </a:p>
         </p:txBody>
@@ -14352,7 +14912,7 @@
       </p:cxnSp>
       <p:pic>
         <p:nvPicPr>
-          <p:cNvPr id="6" name="Picture 5" descr="settings-general-security-preset.png"/>
+          <p:cNvPr id="6" name="Picture 5" descr="settings-general2.png"/>
           <p:cNvPicPr>
             <a:picLocks noChangeAspect="1"/>
           </p:cNvPicPr>
@@ -14367,7 +14927,7 @@
         <p:spPr>
           <a:xfrm>
             <a:off x="566928" y="2240280"/>
-            <a:ext cx="6379122" cy="4160520"/>
+            <a:ext cx="6520914" cy="4160519"/>
           </a:xfrm>
           <a:prstGeom prst="rect">
             <a:avLst/>
@@ -14388,8 +14948,8 @@
         </p:nvSpPr>
         <p:spPr>
           <a:xfrm>
-            <a:off x="3739896" y="3840480"/>
-            <a:ext cx="2633472" cy="1828800"/>
+            <a:off x="2377440" y="2788920"/>
+            <a:ext cx="3977639" cy="594360"/>
           </a:xfrm>
           <a:prstGeom prst="rect">
             <a:avLst/>
@@ -14397,7 +14957,7 @@
           <a:noFill/>
           <a:ln w="28575">
             <a:solidFill>
-              <a:srgbClr val="C13227"/>
+              <a:srgbClr val="D75F00"/>
             </a:solidFill>
           </a:ln>
           <a:effectLst/>
@@ -14432,7 +14992,7 @@
         </p:nvSpPr>
         <p:spPr>
           <a:xfrm>
-            <a:off x="3794760" y="3584448"/>
+            <a:off x="3246119" y="2532888"/>
             <a:ext cx="3063240" cy="219456"/>
           </a:xfrm>
           <a:prstGeom prst="roundRect">
@@ -14441,7 +15001,7 @@
             </a:avLst>
           </a:prstGeom>
           <a:solidFill>
-            <a:srgbClr val="C13227"/>
+            <a:srgbClr val="D75F00"/>
           </a:solidFill>
           <a:ln>
             <a:noFill/>
@@ -14479,7 +15039,7 @@
                 <a:latin typeface="Noto Sans TC"/>
                 <a:ea typeface="Noto Sans TC"/>
               </a:rPr>
-              <a:t>★ 核心防護：Default (終端與目錄外存取強制審查)</a:t>
+              <a:t>★ 關鍵設定：Plan Review Policy = Always Ask</a:t>
             </a:r>
           </a:p>
         </p:txBody>
@@ -14562,12 +15122,12 @@
             <a:r>
               <a:rPr sz="1200" b="1" i="0">
                 <a:solidFill>
-                  <a:srgbClr val="C13227"/>
+                  <a:srgbClr val="D75F00"/>
                 </a:solidFill>
                 <a:latin typeface="Consolas"/>
                 <a:ea typeface="Consolas"/>
               </a:rPr>
-              <a:t>DATA ISOLATION  ·  </a:t>
+              <a:t>EXECUTION SAFEGUARD  ·  </a:t>
             </a:r>
             <a:r>
               <a:rPr sz="1200" b="0" i="0">
@@ -14577,7 +15137,7 @@
                 <a:latin typeface="Noto Sans TC"/>
                 <a:ea typeface="Noto Sans TC"/>
               </a:rPr>
-              <a:t>資安紅線防護</a:t>
+              <a:t>執行把關防線</a:t>
             </a:r>
           </a:p>
         </p:txBody>
@@ -14617,7 +15177,7 @@
                 <a:latin typeface="Noto Sans TC"/>
                 <a:ea typeface="Noto Sans TC"/>
               </a:rPr>
-              <a:t>四種安全預設與院內合規底線</a:t>
+              <a:t>堅持「先看計畫再放行」的操作原則</a:t>
             </a:r>
           </a:p>
         </p:txBody>
@@ -14688,12 +15248,12 @@
             <a:r>
               <a:rPr sz="1200" b="1" i="0">
                 <a:solidFill>
-                  <a:srgbClr val="C13227"/>
-                </a:solidFill>
-                <a:latin typeface="Noto Sans TC"/>
-                <a:ea typeface="Noto Sans TC"/>
-              </a:rPr>
-              <a:t>① Default（推薦 · 院內唯一規範）</a:t>
+                  <a:srgbClr val="D75F00"/>
+                </a:solidFill>
+                <a:latin typeface="Noto Sans TC"/>
+                <a:ea typeface="Noto Sans TC"/>
+              </a:rPr>
+              <a:t>① Always Ask 的防護機制</a:t>
             </a:r>
           </a:p>
           <a:p>
@@ -14713,7 +15273,7 @@
                 <a:latin typeface="Noto Sans TC"/>
                 <a:ea typeface="Noto Sans TC"/>
               </a:rPr>
-              <a:t>▸ 手動審查指令：</a:t>
+              <a:t>▸ 強制中斷等待批准：</a:t>
             </a:r>
             <a:r>
               <a:rPr sz="1200" b="0" i="0">
@@ -14723,7 +15283,7 @@
                 <a:latin typeface="Noto Sans TC"/>
                 <a:ea typeface="Noto Sans TC"/>
               </a:rPr>
-              <a:t>所有涉及系統終端機之操作，皆需人工檢視並按確認。</a:t>
+              <a:t>遇批次檔案移動、刪除或覆蓋，AI 必須停手呈報計畫。</a:t>
             </a:r>
           </a:p>
           <a:p>
@@ -14743,7 +15303,7 @@
                 <a:latin typeface="Noto Sans TC"/>
                 <a:ea typeface="Noto Sans TC"/>
               </a:rPr>
-              <a:t>▸ 目錄外隔離：</a:t>
+              <a:t>▸ 點選 Proceed 始得執行：</a:t>
             </a:r>
             <a:r>
               <a:rPr sz="1200" b="0" i="0">
@@ -14753,7 +15313,7 @@
                 <a:latin typeface="Noto Sans TC"/>
                 <a:ea typeface="Noto Sans TC"/>
               </a:rPr>
-              <a:t>嚴格禁止 AI 自主讀寫工作專案資料夾外的任何本機檔案。</a:t>
+              <a:t>只有使用者在介面確認計畫無誤後，代理人才獲准動手。</a:t>
             </a:r>
           </a:p>
           <a:p>
@@ -14768,12 +15328,12 @@
             <a:r>
               <a:rPr sz="1200" b="1" i="0">
                 <a:solidFill>
-                  <a:srgbClr val="1A1714"/>
-                </a:solidFill>
-                <a:latin typeface="Noto Sans TC"/>
-                <a:ea typeface="Noto Sans TC"/>
-              </a:rPr>
-              <a:t>② Full Machine 與 Turbo 之危害</a:t>
+                  <a:srgbClr val="D75F00"/>
+                </a:solidFill>
+                <a:latin typeface="Noto Sans TC"/>
+                <a:ea typeface="Noto Sans TC"/>
+              </a:rPr>
+              <a:t>② 善用 /plan 斜線指令</a:t>
             </a:r>
           </a:p>
           <a:p>
@@ -14793,7 +15353,7 @@
                 <a:latin typeface="Noto Sans TC"/>
                 <a:ea typeface="Noto Sans TC"/>
               </a:rPr>
-              <a:t>▸ Full Machine 風險：</a:t>
+              <a:t>▸ 主動啟動規劃模式：</a:t>
             </a:r>
             <a:r>
               <a:rPr sz="1200" b="0" i="0">
@@ -14803,7 +15363,7 @@
                 <a:latin typeface="Noto Sans TC"/>
                 <a:ea typeface="Noto Sans TC"/>
               </a:rPr>
-              <a:t>允許跨全機所有磁區讀寫，容易誤觸個人隱私或系統檔。</a:t>
+              <a:t>複雜任務前輸入 /plan，要求 AI 先梳理步驟清單與邊界。</a:t>
             </a:r>
           </a:p>
           <a:p>
@@ -14823,7 +15383,7 @@
                 <a:latin typeface="Noto Sans TC"/>
                 <a:ea typeface="Noto Sans TC"/>
               </a:rPr>
-              <a:t>▸ Turbo Mode 嚴禁啟用：</a:t>
+              <a:t>▸ 消除 95% 溝通落差：</a:t>
             </a:r>
             <a:r>
               <a:rPr sz="1200" b="0" i="0">
@@ -14833,7 +15393,7 @@
                 <a:latin typeface="Noto Sans TC"/>
                 <a:ea typeface="Noto Sans TC"/>
               </a:rPr>
-              <a:t>完全解除一切安全審查屏障，院內環境一律嚴禁使用。</a:t>
+              <a:t>在投入實際修改前釐清目錄、格式與邏輯，大幅降低試錯成本。</a:t>
             </a:r>
           </a:p>
           <a:p>
@@ -14848,12 +15408,12 @@
             <a:r>
               <a:rPr sz="1200" b="1" i="0">
                 <a:solidFill>
-                  <a:srgbClr val="1A1714"/>
-                </a:solidFill>
-                <a:latin typeface="Noto Sans TC"/>
-                <a:ea typeface="Noto Sans TC"/>
-              </a:rPr>
-              <a:t>③ 遵循中研院資安守則</a:t>
+                  <a:srgbClr val="D75F00"/>
+                </a:solidFill>
+                <a:latin typeface="Noto Sans TC"/>
+                <a:ea typeface="Noto Sans TC"/>
+              </a:rPr>
+              <a:t>③ 中研院職員最佳實踐</a:t>
             </a:r>
           </a:p>
           <a:p>
@@ -14873,7 +15433,7 @@
                 <a:latin typeface="Noto Sans TC"/>
                 <a:ea typeface="Noto Sans TC"/>
               </a:rPr>
-              <a:t>▸ 敏感資料不落地：</a:t>
+              <a:t>▸ 禁止切換為 Never Ask：</a:t>
             </a:r>
             <a:r>
               <a:rPr sz="1200" b="0" i="0">
@@ -14883,7 +15443,7 @@
                 <a:latin typeface="Noto Sans TC"/>
                 <a:ea typeface="Noto Sans TC"/>
               </a:rPr>
-              <a:t>涉及未公開學術數據或個資，切勿開啟任意存取許可權。</a:t>
+              <a:t>日常行政與學術研究嚴禁關閉計畫確認，保持操作透明可稽。</a:t>
             </a:r>
           </a:p>
         </p:txBody>
@@ -16341,6 +16901,772 @@
 </file>
 
 <file path=ppt/slides/slide20.xml><?xml version="1.0" encoding="utf-8"?>
+<p:sld xmlns:a="http://schemas.openxmlformats.org/drawingml/2006/main" xmlns:p="http://schemas.openxmlformats.org/presentationml/2006/main" xmlns:r="http://schemas.openxmlformats.org/officeDocument/2006/relationships">
+  <p:cSld>
+    <p:bg>
+      <p:bgPr>
+        <a:solidFill>
+          <a:srgbClr val="FAF8F4"/>
+        </a:solidFill>
+        <a:effectLst/>
+      </p:bgPr>
+    </p:bg>
+    <p:spTree>
+      <p:nvGrpSpPr>
+        <p:cNvPr id="1" name=""/>
+        <p:cNvGrpSpPr/>
+        <p:nvPr/>
+      </p:nvGrpSpPr>
+      <p:grpSpPr/>
+      <p:sp>
+        <p:nvSpPr>
+          <p:cNvPr id="2" name="TextBox 1"/>
+          <p:cNvSpPr txBox="1"/>
+          <p:nvPr/>
+        </p:nvSpPr>
+        <p:spPr>
+          <a:xfrm>
+            <a:off x="566928" y="384048"/>
+            <a:ext cx="6858000" cy="274320"/>
+          </a:xfrm>
+          <a:prstGeom prst="rect">
+            <a:avLst/>
+          </a:prstGeom>
+          <a:noFill/>
+        </p:spPr>
+        <p:txBody>
+          <a:bodyPr wrap="square" anchor="t" lIns="0" rIns="0" tIns="0" bIns="0">
+            <a:spAutoFit/>
+          </a:bodyPr>
+          <a:lstStyle/>
+          <a:p>
+            <a:pPr algn="l">
+              <a:spcAft>
+                <a:spcPts val="400"/>
+              </a:spcAft>
+            </a:pPr>
+            <a:r>
+              <a:rPr sz="1200" b="1" i="0">
+                <a:solidFill>
+                  <a:srgbClr val="D75F00"/>
+                </a:solidFill>
+                <a:latin typeface="Consolas"/>
+                <a:ea typeface="Consolas"/>
+              </a:rPr>
+              <a:t>// 04</a:t>
+            </a:r>
+            <a:r>
+              <a:rPr sz="1200" b="0" i="0">
+                <a:solidFill>
+                  <a:srgbClr val="D75F00"/>
+                </a:solidFill>
+                <a:latin typeface="Consolas"/>
+                <a:ea typeface="Consolas"/>
+              </a:rPr>
+              <a:t>    BEST PRACTICES</a:t>
+            </a:r>
+          </a:p>
+        </p:txBody>
+      </p:sp>
+      <p:sp>
+        <p:nvSpPr>
+          <p:cNvPr id="3" name="TextBox 2"/>
+          <p:cNvSpPr txBox="1"/>
+          <p:nvPr/>
+        </p:nvSpPr>
+        <p:spPr>
+          <a:xfrm>
+            <a:off x="566928" y="786384"/>
+            <a:ext cx="11057839" cy="1097280"/>
+          </a:xfrm>
+          <a:prstGeom prst="rect">
+            <a:avLst/>
+          </a:prstGeom>
+          <a:noFill/>
+        </p:spPr>
+        <p:txBody>
+          <a:bodyPr wrap="square" anchor="t" lIns="0" rIns="0" tIns="0" bIns="0">
+            <a:spAutoFit/>
+          </a:bodyPr>
+          <a:lstStyle/>
+          <a:p>
+            <a:pPr algn="l">
+              <a:lnSpc>
+                <a:spcPct val="108000"/>
+              </a:lnSpc>
+              <a:spcAft>
+                <a:spcPts val="400"/>
+              </a:spcAft>
+            </a:pPr>
+            <a:r>
+              <a:rPr sz="2800" b="1" i="0">
+                <a:solidFill>
+                  <a:srgbClr val="D75F00"/>
+                </a:solidFill>
+                <a:latin typeface="Noto Sans TC"/>
+                <a:ea typeface="Noto Sans TC"/>
+              </a:rPr>
+              <a:t>防線二實體設定：安全沙箱等級</a:t>
+            </a:r>
+            <a:r>
+              <a:rPr sz="2800" b="1" i="0">
+                <a:solidFill>
+                  <a:srgbClr val="1A1714"/>
+                </a:solidFill>
+                <a:latin typeface="Noto Sans TC"/>
+                <a:ea typeface="Noto Sans TC"/>
+              </a:rPr>
+              <a:t>：堅守 Default 預設沙箱防護隔離</a:t>
+            </a:r>
+          </a:p>
+        </p:txBody>
+      </p:sp>
+      <p:sp>
+        <p:nvSpPr>
+          <p:cNvPr id="4" name="TextBox 3"/>
+          <p:cNvSpPr txBox="1"/>
+          <p:nvPr/>
+        </p:nvSpPr>
+        <p:spPr>
+          <a:xfrm>
+            <a:off x="566928" y="1444752"/>
+            <a:ext cx="11057839" cy="411480"/>
+          </a:xfrm>
+          <a:prstGeom prst="rect">
+            <a:avLst/>
+          </a:prstGeom>
+          <a:noFill/>
+        </p:spPr>
+        <p:txBody>
+          <a:bodyPr wrap="square" anchor="t" lIns="0" rIns="0" tIns="0" bIns="0">
+            <a:spAutoFit/>
+          </a:bodyPr>
+          <a:lstStyle/>
+          <a:p>
+            <a:pPr algn="l">
+              <a:lnSpc>
+                <a:spcPct val="125000"/>
+              </a:lnSpc>
+              <a:spcAft>
+                <a:spcPts val="400"/>
+              </a:spcAft>
+            </a:pPr>
+            <a:r>
+              <a:rPr sz="1600" b="0" i="0">
+                <a:solidFill>
+                  <a:srgbClr val="8A8177"/>
+                </a:solidFill>
+                <a:latin typeface="Noto Sans TC"/>
+                <a:ea typeface="Noto Sans TC"/>
+              </a:rPr>
+              <a:t>把守資安邊界：將</a:t>
+            </a:r>
+            <a:r>
+              <a:rPr sz="1600" b="1" i="0">
+                <a:solidFill>
+                  <a:srgbClr val="1A1714"/>
+                </a:solidFill>
+                <a:latin typeface="Noto Sans TC"/>
+                <a:ea typeface="Noto Sans TC"/>
+              </a:rPr>
+              <a:t>Security Preset 維持為 Default</a:t>
+            </a:r>
+            <a:r>
+              <a:rPr sz="1600" b="0" i="0">
+                <a:solidFill>
+                  <a:srgbClr val="8A8177"/>
+                </a:solidFill>
+                <a:latin typeface="Noto Sans TC"/>
+                <a:ea typeface="Noto Sans TC"/>
+              </a:rPr>
+              <a:t>，所有終端指令與跨目錄檔案存取皆需人工逐條審查。</a:t>
+            </a:r>
+          </a:p>
+        </p:txBody>
+      </p:sp>
+      <p:cxnSp>
+        <p:nvCxnSpPr>
+          <p:cNvPr id="5" name="Connector 4"/>
+          <p:cNvCxnSpPr/>
+          <p:nvPr/>
+        </p:nvCxnSpPr>
+        <p:spPr>
+          <a:xfrm>
+            <a:off x="566928" y="2011680"/>
+            <a:ext cx="11057839" cy="0"/>
+          </a:xfrm>
+          <a:prstGeom prst="line">
+            <a:avLst/>
+          </a:prstGeom>
+          <a:ln w="12700">
+            <a:solidFill>
+              <a:srgbClr val="DED8CE"/>
+            </a:solidFill>
+          </a:ln>
+          <a:effectLst/>
+        </p:spPr>
+        <p:style>
+          <a:lnRef idx="2">
+            <a:schemeClr val="accent1"/>
+          </a:lnRef>
+          <a:fillRef idx="0">
+            <a:schemeClr val="accent1"/>
+          </a:fillRef>
+          <a:effectRef idx="1">
+            <a:schemeClr val="accent1"/>
+          </a:effectRef>
+          <a:fontRef idx="minor">
+            <a:schemeClr val="tx1"/>
+          </a:fontRef>
+        </p:style>
+      </p:cxnSp>
+      <p:pic>
+        <p:nvPicPr>
+          <p:cNvPr id="6" name="Picture 5" descr="settings-general-security-preset.png"/>
+          <p:cNvPicPr>
+            <a:picLocks noChangeAspect="1"/>
+          </p:cNvPicPr>
+          <p:nvPr/>
+        </p:nvPicPr>
+        <p:blipFill>
+          <a:blip r:embed="rId2"/>
+          <a:stretch>
+            <a:fillRect/>
+          </a:stretch>
+        </p:blipFill>
+        <p:spPr>
+          <a:xfrm>
+            <a:off x="566928" y="2240280"/>
+            <a:ext cx="6379122" cy="4160520"/>
+          </a:xfrm>
+          <a:prstGeom prst="rect">
+            <a:avLst/>
+          </a:prstGeom>
+          <a:ln w="12700">
+            <a:solidFill>
+              <a:srgbClr val="E4DED4"/>
+            </a:solidFill>
+          </a:ln>
+          <a:effectLst/>
+        </p:spPr>
+      </p:pic>
+      <p:sp>
+        <p:nvSpPr>
+          <p:cNvPr id="7" name="Rectangle 6"/>
+          <p:cNvSpPr/>
+          <p:nvPr/>
+        </p:nvSpPr>
+        <p:spPr>
+          <a:xfrm>
+            <a:off x="3739896" y="3840480"/>
+            <a:ext cx="2633472" cy="1828800"/>
+          </a:xfrm>
+          <a:prstGeom prst="rect">
+            <a:avLst/>
+          </a:prstGeom>
+          <a:noFill/>
+          <a:ln w="28575">
+            <a:solidFill>
+              <a:srgbClr val="C13227"/>
+            </a:solidFill>
+          </a:ln>
+          <a:effectLst/>
+        </p:spPr>
+        <p:style>
+          <a:lnRef idx="1">
+            <a:schemeClr val="accent1"/>
+          </a:lnRef>
+          <a:fillRef idx="3">
+            <a:schemeClr val="accent1"/>
+          </a:fillRef>
+          <a:effectRef idx="2">
+            <a:schemeClr val="accent1"/>
+          </a:effectRef>
+          <a:fontRef idx="minor">
+            <a:schemeClr val="lt1"/>
+          </a:fontRef>
+        </p:style>
+        <p:txBody>
+          <a:bodyPr rtlCol="0" anchor="ctr"/>
+          <a:lstStyle/>
+          <a:p>
+            <a:pPr algn="ctr"/>
+          </a:p>
+        </p:txBody>
+      </p:sp>
+      <p:sp>
+        <p:nvSpPr>
+          <p:cNvPr id="8" name="Rounded Rectangle 7"/>
+          <p:cNvSpPr/>
+          <p:nvPr/>
+        </p:nvSpPr>
+        <p:spPr>
+          <a:xfrm>
+            <a:off x="3794760" y="3584448"/>
+            <a:ext cx="3063240" cy="219456"/>
+          </a:xfrm>
+          <a:prstGeom prst="roundRect">
+            <a:avLst>
+              <a:gd name="adj" fmla="val 50000"/>
+            </a:avLst>
+          </a:prstGeom>
+          <a:solidFill>
+            <a:srgbClr val="C13227"/>
+          </a:solidFill>
+          <a:ln>
+            <a:noFill/>
+          </a:ln>
+          <a:effectLst/>
+        </p:spPr>
+        <p:style>
+          <a:lnRef idx="1">
+            <a:schemeClr val="accent1"/>
+          </a:lnRef>
+          <a:fillRef idx="3">
+            <a:schemeClr val="accent1"/>
+          </a:fillRef>
+          <a:effectRef idx="2">
+            <a:schemeClr val="accent1"/>
+          </a:effectRef>
+          <a:fontRef idx="minor">
+            <a:schemeClr val="lt1"/>
+          </a:fontRef>
+        </p:style>
+        <p:txBody>
+          <a:bodyPr rtlCol="0" anchor="ctr" lIns="36576" rIns="36576" tIns="0" bIns="0" wrap="none"/>
+          <a:lstStyle/>
+          <a:p>
+            <a:pPr algn="ctr">
+              <a:spcAft>
+                <a:spcPts val="400"/>
+              </a:spcAft>
+            </a:pPr>
+            <a:r>
+              <a:rPr sz="1200" b="1" i="0">
+                <a:solidFill>
+                  <a:srgbClr val="F5F2EC"/>
+                </a:solidFill>
+                <a:latin typeface="Noto Sans TC"/>
+                <a:ea typeface="Noto Sans TC"/>
+              </a:rPr>
+              <a:t>★ 核心防護：Default (終端與目錄外存取強制審查)</a:t>
+            </a:r>
+          </a:p>
+        </p:txBody>
+      </p:sp>
+      <p:sp>
+        <p:nvSpPr>
+          <p:cNvPr id="9" name="Rounded Rectangle 8"/>
+          <p:cNvSpPr/>
+          <p:nvPr/>
+        </p:nvSpPr>
+        <p:spPr>
+          <a:xfrm>
+            <a:off x="7406640" y="2240280"/>
+            <a:ext cx="4215384" cy="4160520"/>
+          </a:xfrm>
+          <a:prstGeom prst="roundRect">
+            <a:avLst>
+              <a:gd name="adj" fmla="val 6000"/>
+            </a:avLst>
+          </a:prstGeom>
+          <a:solidFill>
+            <a:srgbClr val="FFFFFE"/>
+          </a:solidFill>
+          <a:ln w="12700">
+            <a:solidFill>
+              <a:srgbClr val="E4DED4"/>
+            </a:solidFill>
+          </a:ln>
+          <a:effectLst/>
+        </p:spPr>
+        <p:style>
+          <a:lnRef idx="1">
+            <a:schemeClr val="accent1"/>
+          </a:lnRef>
+          <a:fillRef idx="3">
+            <a:schemeClr val="accent1"/>
+          </a:fillRef>
+          <a:effectRef idx="2">
+            <a:schemeClr val="accent1"/>
+          </a:effectRef>
+          <a:fontRef idx="minor">
+            <a:schemeClr val="lt1"/>
+          </a:fontRef>
+        </p:style>
+        <p:txBody>
+          <a:bodyPr rtlCol="0" anchor="ctr"/>
+          <a:lstStyle/>
+          <a:p>
+            <a:pPr algn="ctr"/>
+          </a:p>
+        </p:txBody>
+      </p:sp>
+      <p:sp>
+        <p:nvSpPr>
+          <p:cNvPr id="10" name="TextBox 9"/>
+          <p:cNvSpPr txBox="1"/>
+          <p:nvPr/>
+        </p:nvSpPr>
+        <p:spPr>
+          <a:xfrm>
+            <a:off x="7589520" y="2404872"/>
+            <a:ext cx="3849624" cy="256032"/>
+          </a:xfrm>
+          <a:prstGeom prst="rect">
+            <a:avLst/>
+          </a:prstGeom>
+          <a:noFill/>
+        </p:spPr>
+        <p:txBody>
+          <a:bodyPr wrap="square" anchor="t" lIns="0" rIns="0" tIns="0" bIns="0">
+            <a:spAutoFit/>
+          </a:bodyPr>
+          <a:lstStyle/>
+          <a:p>
+            <a:pPr algn="l">
+              <a:spcAft>
+                <a:spcPts val="400"/>
+              </a:spcAft>
+            </a:pPr>
+            <a:r>
+              <a:rPr sz="1200" b="1" i="0">
+                <a:solidFill>
+                  <a:srgbClr val="C13227"/>
+                </a:solidFill>
+                <a:latin typeface="Consolas"/>
+                <a:ea typeface="Consolas"/>
+              </a:rPr>
+              <a:t>DATA ISOLATION  ·  </a:t>
+            </a:r>
+            <a:r>
+              <a:rPr sz="1200" b="0" i="0">
+                <a:solidFill>
+                  <a:srgbClr val="8A8177"/>
+                </a:solidFill>
+                <a:latin typeface="Noto Sans TC"/>
+                <a:ea typeface="Noto Sans TC"/>
+              </a:rPr>
+              <a:t>資安紅線防護</a:t>
+            </a:r>
+          </a:p>
+        </p:txBody>
+      </p:sp>
+      <p:sp>
+        <p:nvSpPr>
+          <p:cNvPr id="11" name="TextBox 10"/>
+          <p:cNvSpPr txBox="1"/>
+          <p:nvPr/>
+        </p:nvSpPr>
+        <p:spPr>
+          <a:xfrm>
+            <a:off x="7589520" y="2679192"/>
+            <a:ext cx="3849624" cy="347472"/>
+          </a:xfrm>
+          <a:prstGeom prst="rect">
+            <a:avLst/>
+          </a:prstGeom>
+          <a:noFill/>
+        </p:spPr>
+        <p:txBody>
+          <a:bodyPr wrap="square" anchor="t" lIns="0" rIns="0" tIns="0" bIns="0">
+            <a:spAutoFit/>
+          </a:bodyPr>
+          <a:lstStyle/>
+          <a:p>
+            <a:pPr algn="l">
+              <a:spcAft>
+                <a:spcPts val="400"/>
+              </a:spcAft>
+            </a:pPr>
+            <a:r>
+              <a:rPr sz="1600" b="1" i="0">
+                <a:solidFill>
+                  <a:srgbClr val="1A1714"/>
+                </a:solidFill>
+                <a:latin typeface="Noto Sans TC"/>
+                <a:ea typeface="Noto Sans TC"/>
+              </a:rPr>
+              <a:t>四種安全預設與院內合規底線</a:t>
+            </a:r>
+          </a:p>
+        </p:txBody>
+      </p:sp>
+      <p:cxnSp>
+        <p:nvCxnSpPr>
+          <p:cNvPr id="12" name="Connector 11"/>
+          <p:cNvCxnSpPr/>
+          <p:nvPr/>
+        </p:nvCxnSpPr>
+        <p:spPr>
+          <a:xfrm>
+            <a:off x="7589520" y="3081528"/>
+            <a:ext cx="3849624" cy="0"/>
+          </a:xfrm>
+          <a:prstGeom prst="line">
+            <a:avLst/>
+          </a:prstGeom>
+          <a:ln w="12700">
+            <a:solidFill>
+              <a:srgbClr val="DED8CE"/>
+            </a:solidFill>
+          </a:ln>
+          <a:effectLst/>
+        </p:spPr>
+        <p:style>
+          <a:lnRef idx="2">
+            <a:schemeClr val="accent1"/>
+          </a:lnRef>
+          <a:fillRef idx="0">
+            <a:schemeClr val="accent1"/>
+          </a:fillRef>
+          <a:effectRef idx="1">
+            <a:schemeClr val="accent1"/>
+          </a:effectRef>
+          <a:fontRef idx="minor">
+            <a:schemeClr val="tx1"/>
+          </a:fontRef>
+        </p:style>
+      </p:cxnSp>
+      <p:sp>
+        <p:nvSpPr>
+          <p:cNvPr id="13" name="TextBox 12"/>
+          <p:cNvSpPr txBox="1"/>
+          <p:nvPr/>
+        </p:nvSpPr>
+        <p:spPr>
+          <a:xfrm>
+            <a:off x="7589520" y="3191256"/>
+            <a:ext cx="3849624" cy="3108960"/>
+          </a:xfrm>
+          <a:prstGeom prst="rect">
+            <a:avLst/>
+          </a:prstGeom>
+          <a:noFill/>
+        </p:spPr>
+        <p:txBody>
+          <a:bodyPr wrap="square" anchor="t" lIns="0" rIns="0" tIns="0" bIns="0">
+            <a:spAutoFit/>
+          </a:bodyPr>
+          <a:lstStyle/>
+          <a:p>
+            <a:pPr algn="l">
+              <a:spcAft>
+                <a:spcPts val="400"/>
+              </a:spcAft>
+            </a:pPr>
+            <a:r>
+              <a:rPr sz="1200" b="1" i="0">
+                <a:solidFill>
+                  <a:srgbClr val="C13227"/>
+                </a:solidFill>
+                <a:latin typeface="Noto Sans TC"/>
+                <a:ea typeface="Noto Sans TC"/>
+              </a:rPr>
+              <a:t>① Default（推薦 · 院內唯一規範）</a:t>
+            </a:r>
+          </a:p>
+          <a:p>
+            <a:pPr algn="l">
+              <a:lnSpc>
+                <a:spcPct val="118000"/>
+              </a:lnSpc>
+              <a:spcAft>
+                <a:spcPts val="300"/>
+              </a:spcAft>
+            </a:pPr>
+            <a:r>
+              <a:rPr sz="1200" b="1" i="0">
+                <a:solidFill>
+                  <a:srgbClr val="1A1714"/>
+                </a:solidFill>
+                <a:latin typeface="Noto Sans TC"/>
+                <a:ea typeface="Noto Sans TC"/>
+              </a:rPr>
+              <a:t>▸ 手動審查指令：</a:t>
+            </a:r>
+            <a:r>
+              <a:rPr sz="1200" b="0" i="0">
+                <a:solidFill>
+                  <a:srgbClr val="4A443D"/>
+                </a:solidFill>
+                <a:latin typeface="Noto Sans TC"/>
+                <a:ea typeface="Noto Sans TC"/>
+              </a:rPr>
+              <a:t>所有涉及系統終端機之操作，皆需人工檢視並按確認。</a:t>
+            </a:r>
+          </a:p>
+          <a:p>
+            <a:pPr algn="l">
+              <a:lnSpc>
+                <a:spcPct val="118000"/>
+              </a:lnSpc>
+              <a:spcAft>
+                <a:spcPts val="0"/>
+              </a:spcAft>
+            </a:pPr>
+            <a:r>
+              <a:rPr sz="1200" b="1" i="0">
+                <a:solidFill>
+                  <a:srgbClr val="1A1714"/>
+                </a:solidFill>
+                <a:latin typeface="Noto Sans TC"/>
+                <a:ea typeface="Noto Sans TC"/>
+              </a:rPr>
+              <a:t>▸ 目錄外隔離：</a:t>
+            </a:r>
+            <a:r>
+              <a:rPr sz="1200" b="0" i="0">
+                <a:solidFill>
+                  <a:srgbClr val="4A443D"/>
+                </a:solidFill>
+                <a:latin typeface="Noto Sans TC"/>
+                <a:ea typeface="Noto Sans TC"/>
+              </a:rPr>
+              <a:t>嚴格禁止 AI 自主讀寫工作專案資料夾外的任何本機檔案。</a:t>
+            </a:r>
+          </a:p>
+          <a:p>
+            <a:pPr algn="l">
+              <a:spcBef>
+                <a:spcPts val="800"/>
+              </a:spcBef>
+              <a:spcAft>
+                <a:spcPts val="400"/>
+              </a:spcAft>
+            </a:pPr>
+            <a:r>
+              <a:rPr sz="1200" b="1" i="0">
+                <a:solidFill>
+                  <a:srgbClr val="1A1714"/>
+                </a:solidFill>
+                <a:latin typeface="Noto Sans TC"/>
+                <a:ea typeface="Noto Sans TC"/>
+              </a:rPr>
+              <a:t>② Full Machine 與 Turbo 之危害</a:t>
+            </a:r>
+          </a:p>
+          <a:p>
+            <a:pPr algn="l">
+              <a:lnSpc>
+                <a:spcPct val="118000"/>
+              </a:lnSpc>
+              <a:spcAft>
+                <a:spcPts val="300"/>
+              </a:spcAft>
+            </a:pPr>
+            <a:r>
+              <a:rPr sz="1200" b="1" i="0">
+                <a:solidFill>
+                  <a:srgbClr val="1A1714"/>
+                </a:solidFill>
+                <a:latin typeface="Noto Sans TC"/>
+                <a:ea typeface="Noto Sans TC"/>
+              </a:rPr>
+              <a:t>▸ Full Machine 風險：</a:t>
+            </a:r>
+            <a:r>
+              <a:rPr sz="1200" b="0" i="0">
+                <a:solidFill>
+                  <a:srgbClr val="4A443D"/>
+                </a:solidFill>
+                <a:latin typeface="Noto Sans TC"/>
+                <a:ea typeface="Noto Sans TC"/>
+              </a:rPr>
+              <a:t>允許跨全機所有磁區讀寫，容易誤觸個人隱私或系統檔。</a:t>
+            </a:r>
+          </a:p>
+          <a:p>
+            <a:pPr algn="l">
+              <a:lnSpc>
+                <a:spcPct val="118000"/>
+              </a:lnSpc>
+              <a:spcAft>
+                <a:spcPts val="0"/>
+              </a:spcAft>
+            </a:pPr>
+            <a:r>
+              <a:rPr sz="1200" b="1" i="0">
+                <a:solidFill>
+                  <a:srgbClr val="1A1714"/>
+                </a:solidFill>
+                <a:latin typeface="Noto Sans TC"/>
+                <a:ea typeface="Noto Sans TC"/>
+              </a:rPr>
+              <a:t>▸ Turbo Mode 嚴禁啟用：</a:t>
+            </a:r>
+            <a:r>
+              <a:rPr sz="1200" b="0" i="0">
+                <a:solidFill>
+                  <a:srgbClr val="4A443D"/>
+                </a:solidFill>
+                <a:latin typeface="Noto Sans TC"/>
+                <a:ea typeface="Noto Sans TC"/>
+              </a:rPr>
+              <a:t>完全解除一切安全審查屏障，院內環境一律嚴禁使用。</a:t>
+            </a:r>
+          </a:p>
+          <a:p>
+            <a:pPr algn="l">
+              <a:spcBef>
+                <a:spcPts val="800"/>
+              </a:spcBef>
+              <a:spcAft>
+                <a:spcPts val="400"/>
+              </a:spcAft>
+            </a:pPr>
+            <a:r>
+              <a:rPr sz="1200" b="1" i="0">
+                <a:solidFill>
+                  <a:srgbClr val="1A1714"/>
+                </a:solidFill>
+                <a:latin typeface="Noto Sans TC"/>
+                <a:ea typeface="Noto Sans TC"/>
+              </a:rPr>
+              <a:t>③ 遵循中研院資安守則</a:t>
+            </a:r>
+          </a:p>
+          <a:p>
+            <a:pPr algn="l">
+              <a:lnSpc>
+                <a:spcPct val="118000"/>
+              </a:lnSpc>
+              <a:spcAft>
+                <a:spcPts val="0"/>
+              </a:spcAft>
+            </a:pPr>
+            <a:r>
+              <a:rPr sz="1200" b="1" i="0">
+                <a:solidFill>
+                  <a:srgbClr val="1A1714"/>
+                </a:solidFill>
+                <a:latin typeface="Noto Sans TC"/>
+                <a:ea typeface="Noto Sans TC"/>
+              </a:rPr>
+              <a:t>▸ 敏感資料不落地：</a:t>
+            </a:r>
+            <a:r>
+              <a:rPr sz="1200" b="0" i="0">
+                <a:solidFill>
+                  <a:srgbClr val="4A443D"/>
+                </a:solidFill>
+                <a:latin typeface="Noto Sans TC"/>
+                <a:ea typeface="Noto Sans TC"/>
+              </a:rPr>
+              <a:t>涉及未公開學術數據或個資，切勿開啟任意存取許可權。</a:t>
+            </a:r>
+          </a:p>
+        </p:txBody>
+      </p:sp>
+    </p:spTree>
+  </p:cSld>
+  <p:clrMapOvr>
+    <a:masterClrMapping/>
+  </p:clrMapOvr>
+</p:sld>
+</file>
+
+<file path=ppt/slides/slide21.xml><?xml version="1.0" encoding="utf-8"?>
 <p:sld xmlns:a="http://schemas.openxmlformats.org/drawingml/2006/main" xmlns:p="http://schemas.openxmlformats.org/presentationml/2006/main" xmlns:r="http://schemas.openxmlformats.org/officeDocument/2006/relationships">
   <p:cSld>
     <p:bg>

</xml_diff>